<commit_message>
feat: Implement header and settings modal components, enhance UI with Tailwind CSS
- Added Header component for sidebar toggle and model selection.
- Introduced SettingsModal for configuring Socratic modes and managing chat history.
- Created reusable UI components: Button, Badge, Card, Dropdown, Input, Modal, Textarea, and CodeBlock.
- Enhanced styling in index.css for a modern look and feel.
- Integrated Tailwind CSS for improved design consistency.
- Added custom scrollbar styles and markdown styling for better readability.
- Updated Vite configuration to support Tailwind CSS and path aliases.
- Included a new model file for Socratic Tutor.
</commit_message>
<xml_diff>
--- a/Clariq_A1_Portrait_Poster.pptx
+++ b/Clariq_A1_Portrait_Poster.pptx
@@ -3097,7 +3097,7 @@
         <p:spPr>
           <a:xfrm>
             <a:off x="0" y="0"/>
-            <a:ext cx="21384158" cy="2194560"/>
+            <a:ext cx="21384158" cy="2057400"/>
           </a:xfrm>
           <a:prstGeom prst="rect">
             <a:avLst/>
@@ -3149,8 +3149,8 @@
         </p:blipFill>
         <p:spPr>
           <a:xfrm>
-            <a:off x="731520" y="320040"/>
-            <a:ext cx="4987853" cy="1554480"/>
+            <a:off x="731520" y="256032"/>
+            <a:ext cx="4841152" cy="1508760"/>
           </a:xfrm>
           <a:prstGeom prst="rect">
             <a:avLst/>
@@ -3165,8 +3165,8 @@
         </p:nvSpPr>
         <p:spPr>
           <a:xfrm>
-            <a:off x="4754880" y="228600"/>
-            <a:ext cx="11430000" cy="1737360"/>
+            <a:off x="4572000" y="164592"/>
+            <a:ext cx="11521440" cy="1737360"/>
           </a:xfrm>
           <a:prstGeom prst="rect">
             <a:avLst/>
@@ -3180,7 +3180,7 @@
           <a:lstStyle/>
           <a:p>
             <a:pPr>
-              <a:defRPr sz="5600" b="1">
+              <a:defRPr sz="5400" b="1">
                 <a:solidFill>
                   <a:srgbClr val="FFFFFF"/>
                 </a:solidFill>
@@ -3189,22 +3189,6 @@
             </a:pPr>
             <a:r>
               <a:t>Clariq</a:t>
-            </a:r>
-          </a:p>
-          <a:p>
-            <a:pPr>
-              <a:spcBef>
-                <a:spcPts val="300"/>
-              </a:spcBef>
-              <a:defRPr sz="2100" b="1">
-                <a:solidFill>
-                  <a:srgbClr val="BAE6FD"/>
-                </a:solidFill>
-                <a:latin typeface="Arial"/>
-              </a:defRPr>
-            </a:pPr>
-            <a:r>
-              <a:t>AI-Powered Socratic Science Tutor with Adaptive Knowledge Tracking</a:t>
             </a:r>
           </a:p>
           <a:p>
@@ -3212,7 +3196,23 @@
               <a:spcBef>
                 <a:spcPts val="200"/>
               </a:spcBef>
-              <a:defRPr sz="1400">
+              <a:defRPr sz="2000" b="1">
+                <a:solidFill>
+                  <a:srgbClr val="BAE6FD"/>
+                </a:solidFill>
+                <a:latin typeface="Arial"/>
+              </a:defRPr>
+            </a:pPr>
+            <a:r>
+              <a:t>AI-Powered Socratic Science Tutor with Adaptive Knowledge Tracking</a:t>
+            </a:r>
+          </a:p>
+          <a:p>
+            <a:pPr>
+              <a:spcBef>
+                <a:spcPts val="200"/>
+              </a:spcBef>
+              <a:defRPr sz="1350">
                 <a:solidFill>
                   <a:srgbClr val="E0F2FE"/>
                 </a:solidFill>
@@ -3233,7 +3233,7 @@
         </p:nvSpPr>
         <p:spPr>
           <a:xfrm>
-            <a:off x="16276320" y="256032"/>
+            <a:off x="16276320" y="201168"/>
             <a:ext cx="4370832" cy="1691640"/>
           </a:xfrm>
           <a:prstGeom prst="rect">
@@ -3248,7 +3248,7 @@
           <a:lstStyle/>
           <a:p>
             <a:pPr algn="r">
-              <a:defRPr sz="1900" b="1">
+              <a:defRPr sz="1800" b="1">
                 <a:solidFill>
                   <a:srgbClr val="FFFFFF"/>
                 </a:solidFill>
@@ -3261,7 +3261,7 @@
           </a:p>
           <a:p>
             <a:pPr algn="r">
-              <a:defRPr sz="1400" b="1">
+              <a:defRPr sz="1350" b="1">
                 <a:solidFill>
                   <a:srgbClr val="F59E0B"/>
                 </a:solidFill>
@@ -3275,9 +3275,9 @@
           <a:p>
             <a:pPr algn="r">
               <a:spcBef>
-                <a:spcPts val="500"/>
+                <a:spcPts val="400"/>
               </a:spcBef>
-              <a:defRPr sz="1700" b="1">
+              <a:defRPr sz="1600" b="1">
                 <a:solidFill>
                   <a:srgbClr val="FFFFFF"/>
                 </a:solidFill>
@@ -3302,8 +3302,8 @@
         </p:nvSpPr>
         <p:spPr>
           <a:xfrm>
-            <a:off x="731520" y="2395728"/>
-            <a:ext cx="11521440" cy="1005840"/>
+            <a:off x="731520" y="2231136"/>
+            <a:ext cx="11521440" cy="822960"/>
           </a:xfrm>
           <a:prstGeom prst="rect">
             <a:avLst/>
@@ -3317,7 +3317,7 @@
           <a:lstStyle/>
           <a:p>
             <a:pPr>
-              <a:defRPr sz="1750" b="1">
+              <a:defRPr sz="1700" b="1">
                 <a:solidFill>
                   <a:srgbClr val="111827"/>
                 </a:solidFill>
@@ -3331,9 +3331,9 @@
           <a:p>
             <a:pPr>
               <a:spcBef>
-                <a:spcPts val="300"/>
+                <a:spcPts val="200"/>
               </a:spcBef>
-              <a:defRPr sz="1400">
+              <a:defRPr sz="1350">
                 <a:solidFill>
                   <a:srgbClr val="374151"/>
                 </a:solidFill>
@@ -3354,8 +3354,8 @@
         </p:nvSpPr>
         <p:spPr>
           <a:xfrm>
-            <a:off x="12435840" y="2304288"/>
-            <a:ext cx="8211312" cy="1078992"/>
+            <a:off x="12435840" y="2176272"/>
+            <a:ext cx="8211312" cy="914400"/>
           </a:xfrm>
           <a:prstGeom prst="roundRect">
             <a:avLst/>
@@ -3399,8 +3399,8 @@
         </p:nvSpPr>
         <p:spPr>
           <a:xfrm>
-            <a:off x="12573000" y="2359152"/>
-            <a:ext cx="7936992" cy="969264"/>
+            <a:off x="12573000" y="2231136"/>
+            <a:ext cx="7936992" cy="822960"/>
           </a:xfrm>
           <a:prstGeom prst="rect">
             <a:avLst/>
@@ -3414,7 +3414,7 @@
           <a:lstStyle/>
           <a:p>
             <a:pPr>
-              <a:defRPr sz="1600" b="1">
+              <a:defRPr sz="1550" b="1">
                 <a:solidFill>
                   <a:srgbClr val="111827"/>
                 </a:solidFill>
@@ -3430,7 +3430,7 @@
               <a:spcBef>
                 <a:spcPts val="200"/>
               </a:spcBef>
-              <a:defRPr sz="1200">
+              <a:defRPr sz="1100">
                 <a:solidFill>
                   <a:srgbClr val="374151"/>
                 </a:solidFill>
@@ -3445,517 +3445,20 @@
       </p:sp>
       <p:sp>
         <p:nvSpPr>
-          <p:cNvPr id="9" name="TextBox 8"/>
-          <p:cNvSpPr txBox="1"/>
-          <p:nvPr/>
-        </p:nvSpPr>
-        <p:spPr>
-          <a:xfrm>
-            <a:off x="731520" y="3566160"/>
-            <a:ext cx="7406640" cy="502920"/>
-          </a:xfrm>
-          <a:prstGeom prst="rect">
-            <a:avLst/>
-          </a:prstGeom>
-          <a:noFill/>
-        </p:spPr>
-        <p:txBody>
-          <a:bodyPr wrap="square" lIns="0" tIns="0" rIns="0" bIns="0">
-            <a:spAutoFit/>
-          </a:bodyPr>
-          <a:lstStyle/>
-          <a:p>
-            <a:pPr>
-              <a:defRPr sz="2300" b="1">
-                <a:solidFill>
-                  <a:srgbClr val="111827"/>
-                </a:solidFill>
-                <a:latin typeface="Arial"/>
-              </a:defRPr>
-            </a:pPr>
-            <a:r>
-              <a:t>Problem &amp; Background Context</a:t>
-            </a:r>
-          </a:p>
-        </p:txBody>
-      </p:sp>
-      <p:sp>
-        <p:nvSpPr>
-          <p:cNvPr id="10" name="TextBox 9"/>
-          <p:cNvSpPr txBox="1"/>
-          <p:nvPr/>
-        </p:nvSpPr>
-        <p:spPr>
-          <a:xfrm>
-            <a:off x="731520" y="3977639"/>
-            <a:ext cx="7406640" cy="1600200"/>
-          </a:xfrm>
-          <a:prstGeom prst="rect">
-            <a:avLst/>
-          </a:prstGeom>
-          <a:noFill/>
-        </p:spPr>
-        <p:txBody>
-          <a:bodyPr wrap="square" lIns="0" tIns="0" rIns="0" bIns="0">
-            <a:spAutoFit/>
-          </a:bodyPr>
-          <a:lstStyle/>
-          <a:p>
-            <a:pPr>
-              <a:spcAft>
-                <a:spcPts val="400"/>
-              </a:spcAft>
-            </a:pPr>
-            <a:r>
-              <a:rPr b="1" sz="1250">
-                <a:solidFill>
-                  <a:srgbClr val="003366"/>
-                </a:solidFill>
-                <a:latin typeface="Arial"/>
-              </a:rPr>
-              <a:t>•  National Failure Crisis: </a:t>
-            </a:r>
-            <a:r>
-              <a:rPr sz="1200">
-                <a:solidFill>
-                  <a:srgbClr val="374151"/>
-                </a:solidFill>
-                <a:latin typeface="Arial"/>
-              </a:rPr>
-              <a:t>In the 2080-81 Secondary Education Examination (SEE), 79,271 students (15.42%) were marked Non-Graded (NG) in Science &amp; Technology—the highest academic deficit subject (MoEST, 2024).</a:t>
-            </a:r>
-          </a:p>
-          <a:p>
-            <a:pPr>
-              <a:spcAft>
-                <a:spcPts val="400"/>
-              </a:spcAft>
-            </a:pPr>
-            <a:r>
-              <a:rPr b="1" sz="1250">
-                <a:solidFill>
-                  <a:srgbClr val="003366"/>
-                </a:solidFill>
-                <a:latin typeface="Arial"/>
-              </a:rPr>
-              <a:t>•  The AI 'Cognitive Crutch' Hazard: </a:t>
-            </a:r>
-            <a:r>
-              <a:rPr sz="1200">
-                <a:solidFill>
-                  <a:srgbClr val="374151"/>
-                </a:solidFill>
-                <a:latin typeface="Arial"/>
-              </a:rPr>
-              <a:t>Commercial chatbots (GPT-4o) act as unearned answer dispensers (88% answer dumps), short-circuiting metacognition and inducing cognitive atrophy (Bastani et al., 2025).</a:t>
-            </a:r>
-          </a:p>
-          <a:p>
-            <a:pPr>
-              <a:spcAft>
-                <a:spcPts val="400"/>
-              </a:spcAft>
-            </a:pPr>
-            <a:r>
-              <a:rPr b="1" sz="1250">
-                <a:solidFill>
-                  <a:srgbClr val="003366"/>
-                </a:solidFill>
-                <a:latin typeface="Arial"/>
-              </a:rPr>
-              <a:t>•  Socio-Economic Divide: </a:t>
-            </a:r>
-            <a:r>
-              <a:rPr sz="1200">
-                <a:solidFill>
-                  <a:srgbClr val="374151"/>
-                </a:solidFill>
-                <a:latin typeface="Arial"/>
-              </a:rPr>
-              <a:t>Private tutoring centers cost NPR 2,000–5,000/mo ($15–$40), which is unaffordable for rural families. Public schools face severe 50+:1 pupil-teacher ratios, precluding 1-on-1 scaffolding.</a:t>
-            </a:r>
-          </a:p>
-        </p:txBody>
-      </p:sp>
-      <p:sp>
-        <p:nvSpPr>
-          <p:cNvPr id="11" name="TextBox 10"/>
-          <p:cNvSpPr txBox="1"/>
-          <p:nvPr/>
-        </p:nvSpPr>
-        <p:spPr>
-          <a:xfrm>
-            <a:off x="731520" y="5669280"/>
-            <a:ext cx="7406640" cy="502920"/>
-          </a:xfrm>
-          <a:prstGeom prst="rect">
-            <a:avLst/>
-          </a:prstGeom>
-          <a:noFill/>
-        </p:spPr>
-        <p:txBody>
-          <a:bodyPr wrap="square" lIns="0" tIns="0" rIns="0" bIns="0">
-            <a:spAutoFit/>
-          </a:bodyPr>
-          <a:lstStyle/>
-          <a:p>
-            <a:pPr>
-              <a:defRPr sz="2300" b="1">
-                <a:solidFill>
-                  <a:srgbClr val="111827"/>
-                </a:solidFill>
-                <a:latin typeface="Arial"/>
-              </a:defRPr>
-            </a:pPr>
-            <a:r>
-              <a:t>Identified Research Gap</a:t>
-            </a:r>
-          </a:p>
-        </p:txBody>
-      </p:sp>
-      <p:sp>
-        <p:nvSpPr>
-          <p:cNvPr id="12" name="TextBox 11"/>
-          <p:cNvSpPr txBox="1"/>
-          <p:nvPr/>
-        </p:nvSpPr>
-        <p:spPr>
-          <a:xfrm>
-            <a:off x="731520" y="6080760"/>
-            <a:ext cx="7406640" cy="1005840"/>
-          </a:xfrm>
-          <a:prstGeom prst="rect">
-            <a:avLst/>
-          </a:prstGeom>
-          <a:noFill/>
-        </p:spPr>
-        <p:txBody>
-          <a:bodyPr wrap="square" lIns="0" tIns="0" rIns="0" bIns="0">
-            <a:spAutoFit/>
-          </a:bodyPr>
-          <a:lstStyle/>
-          <a:p>
-            <a:pPr>
-              <a:defRPr sz="1250">
-                <a:solidFill>
-                  <a:srgbClr val="374151"/>
-                </a:solidFill>
-                <a:latin typeface="Arial"/>
-              </a:defRPr>
-            </a:pPr>
-            <a:r>
-              <a:t>Existing educational AI tools either act as didactic answer dispensers without national curriculum grounding, or rely on rigid rule-based ITS without conversational fluidity. No prior work provides open-weight Socratic dialogue models governed by deterministic turn gating combined with dynamic concept mastery tracking for South Asian national secondary curricula.</a:t>
-            </a:r>
-          </a:p>
-        </p:txBody>
-      </p:sp>
-      <p:sp>
-        <p:nvSpPr>
-          <p:cNvPr id="13" name="TextBox 12"/>
-          <p:cNvSpPr txBox="1"/>
-          <p:nvPr/>
-        </p:nvSpPr>
-        <p:spPr>
-          <a:xfrm>
-            <a:off x="731520" y="7178040"/>
-            <a:ext cx="7406640" cy="502920"/>
-          </a:xfrm>
-          <a:prstGeom prst="rect">
-            <a:avLst/>
-          </a:prstGeom>
-          <a:noFill/>
-        </p:spPr>
-        <p:txBody>
-          <a:bodyPr wrap="square" lIns="0" tIns="0" rIns="0" bIns="0">
-            <a:spAutoFit/>
-          </a:bodyPr>
-          <a:lstStyle/>
-          <a:p>
-            <a:pPr>
-              <a:defRPr sz="2300" b="1">
-                <a:solidFill>
-                  <a:srgbClr val="111827"/>
-                </a:solidFill>
-                <a:latin typeface="Arial"/>
-              </a:defRPr>
-            </a:pPr>
-            <a:r>
-              <a:t>Aim, Objectives &amp; Research Questions</a:t>
-            </a:r>
-          </a:p>
-        </p:txBody>
-      </p:sp>
-      <p:sp>
-        <p:nvSpPr>
-          <p:cNvPr id="14" name="TextBox 13"/>
-          <p:cNvSpPr txBox="1"/>
-          <p:nvPr/>
-        </p:nvSpPr>
-        <p:spPr>
-          <a:xfrm>
-            <a:off x="731520" y="7589520"/>
-            <a:ext cx="7406640" cy="3108960"/>
-          </a:xfrm>
-          <a:prstGeom prst="rect">
-            <a:avLst/>
-          </a:prstGeom>
-          <a:noFill/>
-        </p:spPr>
-        <p:txBody>
-          <a:bodyPr wrap="square" lIns="0" tIns="0" rIns="0" bIns="0">
-            <a:spAutoFit/>
-          </a:bodyPr>
-          <a:lstStyle/>
-          <a:p>
-            <a:pPr>
-              <a:spcAft>
-                <a:spcPts val="400"/>
-              </a:spcAft>
-              <a:defRPr sz="1250" b="1">
-                <a:solidFill>
-                  <a:srgbClr val="111827"/>
-                </a:solidFill>
-                <a:latin typeface="Arial"/>
-              </a:defRPr>
-            </a:pPr>
-            <a:r>
-              <a:t>Research Aim: To design, implement, and empirically pilot Clariq—an AI-powered Socratic science tutor delivering curriculum-grounded dialogue, dynamically tracking mastery across a 135-node Knowledge Graph, and evaluating its pedagogical feasibility against textbook self-study.</a:t>
-            </a:r>
-          </a:p>
-          <a:p>
-            <a:pPr>
-              <a:spcAft>
-                <a:spcPts val="400"/>
-              </a:spcAft>
-              <a:defRPr sz="1150" b="1">
-                <a:solidFill>
-                  <a:srgbClr val="003366"/>
-                </a:solidFill>
-                <a:latin typeface="Arial"/>
-              </a:defRPr>
-            </a:pPr>
-            <a:r>
-              <a:t>• RQ1 (Dialogue Restraint): Can open-weight LLMs, constrained by turn policies and RAG, sustain multi-turn inquiry without leaking direct answers?</a:t>
-            </a:r>
-            <a:br/>
-            <a:r>
-              <a:t>• RQ2 (Mastery Telemetry): Can conversational turns yield reliable concept mastery telemetry across an adaptive knowledge graph to flag struggling students?</a:t>
-            </a:r>
-          </a:p>
-          <a:p>
-            <a:pPr>
-              <a:spcAft>
-                <a:spcPts val="200"/>
-              </a:spcAft>
-              <a:defRPr sz="1100">
-                <a:solidFill>
-                  <a:srgbClr val="374151"/>
-                </a:solidFill>
-                <a:latin typeface="Arial"/>
-              </a:defRPr>
-            </a:pPr>
-            <a:r>
-              <a:t>•  1. Ingest official CDC Class 10 science textbooks into Chroma vector DB</a:t>
-            </a:r>
-          </a:p>
-          <a:p>
-            <a:pPr>
-              <a:spcAft>
-                <a:spcPts val="200"/>
-              </a:spcAft>
-              <a:defRPr sz="1100">
-                <a:solidFill>
-                  <a:srgbClr val="374151"/>
-                </a:solidFill>
-                <a:latin typeface="Arial"/>
-              </a:defRPr>
-            </a:pPr>
-            <a:r>
-              <a:t>•  2. Implement hybrid RAG with lexical candidate reranking (P@3 &gt;= 0.85)</a:t>
-            </a:r>
-          </a:p>
-          <a:p>
-            <a:pPr>
-              <a:spcAft>
-                <a:spcPts val="200"/>
-              </a:spcAft>
-              <a:defRPr sz="1100">
-                <a:solidFill>
-                  <a:srgbClr val="374151"/>
-                </a:solidFill>
-                <a:latin typeface="Arial"/>
-              </a:defRPr>
-            </a:pPr>
-            <a:r>
-              <a:t>•  3. Enforce 5-stage turn policy (turn_policy.py) to suppress answer leakage</a:t>
-            </a:r>
-          </a:p>
-          <a:p>
-            <a:pPr>
-              <a:spcAft>
-                <a:spcPts val="200"/>
-              </a:spcAft>
-              <a:defRPr sz="1100">
-                <a:solidFill>
-                  <a:srgbClr val="374151"/>
-                </a:solidFill>
-                <a:latin typeface="Arial"/>
-              </a:defRPr>
-            </a:pPr>
-            <a:r>
-              <a:t>•  4. Fine-tune open-weight Socratic dialogue model on dual T4 GPUs</a:t>
-            </a:r>
-          </a:p>
-          <a:p>
-            <a:pPr>
-              <a:spcAft>
-                <a:spcPts val="200"/>
-              </a:spcAft>
-              <a:defRPr sz="1100">
-                <a:solidFill>
-                  <a:srgbClr val="374151"/>
-                </a:solidFill>
-                <a:latin typeface="Arial"/>
-              </a:defRPr>
-            </a:pPr>
-            <a:r>
-              <a:t>•  5. Eliminate script collapse via weight merging (Qwen2.5-7B Merged SFT)</a:t>
-            </a:r>
-          </a:p>
-          <a:p>
-            <a:pPr>
-              <a:spcAft>
-                <a:spcPts val="200"/>
-              </a:spcAft>
-              <a:defRPr sz="1100">
-                <a:solidFill>
-                  <a:srgbClr val="374151"/>
-                </a:solidFill>
-                <a:latin typeface="Arial"/>
-              </a:defRPr>
-            </a:pPr>
-            <a:r>
-              <a:t>•  6. Construct 135-node directed knowledge graph across Physics, Chem, Bio</a:t>
-            </a:r>
-          </a:p>
-          <a:p>
-            <a:pPr>
-              <a:spcAft>
-                <a:spcPts val="200"/>
-              </a:spcAft>
-              <a:defRPr sz="1100">
-                <a:solidFill>
-                  <a:srgbClr val="374151"/>
-                </a:solidFill>
-                <a:latin typeface="Arial"/>
-              </a:defRPr>
-            </a:pPr>
-            <a:r>
-              <a:t>•  7. Formulate token-overlap scoring with coherence and rote-copy penalties</a:t>
-            </a:r>
-          </a:p>
-          <a:p>
-            <a:pPr>
-              <a:spcAft>
-                <a:spcPts val="200"/>
-              </a:spcAft>
-              <a:defRPr sz="1100">
-                <a:solidFill>
-                  <a:srgbClr val="374151"/>
-                </a:solidFill>
-                <a:latin typeface="Arial"/>
-              </a:defRPr>
-            </a:pPr>
-            <a:r>
-              <a:t>•  8. Implement Exponential Moving Average (EWMA) mastery updating</a:t>
-            </a:r>
-          </a:p>
-          <a:p>
-            <a:pPr>
-              <a:spcAft>
-                <a:spcPts val="200"/>
-              </a:spcAft>
-              <a:defRPr sz="1100">
-                <a:solidFill>
-                  <a:srgbClr val="374151"/>
-                </a:solidFill>
-                <a:latin typeface="Arial"/>
-              </a:defRPr>
-            </a:pPr>
-            <a:r>
-              <a:t>•  9. Build automated 3-turn persistent confusion diagnostic alerts</a:t>
-            </a:r>
-          </a:p>
-          <a:p>
-            <a:pPr>
-              <a:spcAft>
-                <a:spcPts val="200"/>
-              </a:spcAft>
-              <a:defRPr sz="1100">
-                <a:solidFill>
-                  <a:srgbClr val="374151"/>
-                </a:solidFill>
-                <a:latin typeface="Arial"/>
-              </a:defRPr>
-            </a:pPr>
-            <a:r>
-              <a:t>•  10. Conduct controlled empirical pilot study (N=20) against textbook study</a:t>
-            </a:r>
-          </a:p>
-        </p:txBody>
-      </p:sp>
-      <p:sp>
-        <p:nvSpPr>
-          <p:cNvPr id="15" name="TextBox 14"/>
-          <p:cNvSpPr txBox="1"/>
-          <p:nvPr/>
-        </p:nvSpPr>
-        <p:spPr>
-          <a:xfrm>
-            <a:off x="8549640" y="3566160"/>
-            <a:ext cx="12097512" cy="502920"/>
-          </a:xfrm>
-          <a:prstGeom prst="rect">
-            <a:avLst/>
-          </a:prstGeom>
-          <a:noFill/>
-        </p:spPr>
-        <p:txBody>
-          <a:bodyPr wrap="square" lIns="0" tIns="0" rIns="0" bIns="0">
-            <a:spAutoFit/>
-          </a:bodyPr>
-          <a:lstStyle/>
-          <a:p>
-            <a:pPr>
-              <a:defRPr sz="2300" b="1">
-                <a:solidFill>
-                  <a:srgbClr val="111827"/>
-                </a:solidFill>
-                <a:latin typeface="Arial"/>
-              </a:defRPr>
-            </a:pPr>
-            <a:r>
-              <a:t>Research Methodology &amp; System Frameworks</a:t>
-            </a:r>
-          </a:p>
-        </p:txBody>
-      </p:sp>
-      <p:sp>
-        <p:nvSpPr>
-          <p:cNvPr id="16" name="Rounded Rectangle 15"/>
+          <p:cNvPr id="9" name="Rounded Rectangle 8"/>
           <p:cNvSpPr/>
           <p:nvPr/>
         </p:nvSpPr>
         <p:spPr>
           <a:xfrm>
-            <a:off x="8549640" y="3977639"/>
-            <a:ext cx="3886200" cy="1051560"/>
+            <a:off x="731520" y="3218688"/>
+            <a:ext cx="7406640" cy="2103120"/>
           </a:xfrm>
           <a:prstGeom prst="roundRect">
             <a:avLst/>
           </a:prstGeom>
           <a:solidFill>
-            <a:srgbClr val="F9FAFB"/>
+            <a:srgbClr val="FFFFFF"/>
           </a:solidFill>
           <a:ln w="19050">
             <a:solidFill>
@@ -3987,14 +3490,49 @@
       </p:sp>
       <p:sp>
         <p:nvSpPr>
-          <p:cNvPr id="17" name="TextBox 16"/>
+          <p:cNvPr id="10" name="TextBox 9"/>
           <p:cNvSpPr txBox="1"/>
           <p:nvPr/>
         </p:nvSpPr>
         <p:spPr>
           <a:xfrm>
-            <a:off x="8659367" y="4069079"/>
-            <a:ext cx="3666744" cy="868680"/>
+            <a:off x="868680" y="3273552"/>
+            <a:ext cx="7132320" cy="292608"/>
+          </a:xfrm>
+          <a:prstGeom prst="rect">
+            <a:avLst/>
+          </a:prstGeom>
+          <a:noFill/>
+        </p:spPr>
+        <p:txBody>
+          <a:bodyPr wrap="none">
+            <a:spAutoFit/>
+          </a:bodyPr>
+          <a:lstStyle/>
+          <a:p>
+            <a:pPr>
+              <a:defRPr sz="1600" b="1">
+                <a:solidFill>
+                  <a:srgbClr val="111827"/>
+                </a:solidFill>
+              </a:defRPr>
+            </a:pPr>
+            <a:r>
+              <a:t>Problem &amp; Background Context</a:t>
+            </a:r>
+          </a:p>
+        </p:txBody>
+      </p:sp>
+      <p:sp>
+        <p:nvSpPr>
+          <p:cNvPr id="11" name="TextBox 10"/>
+          <p:cNvSpPr txBox="1"/>
+          <p:nvPr/>
+        </p:nvSpPr>
+        <p:spPr>
+          <a:xfrm>
+            <a:off x="868680" y="3621024"/>
+            <a:ext cx="7132320" cy="1645920"/>
           </a:xfrm>
           <a:prstGeom prst="rect">
             <a:avLst/>
@@ -4008,51 +3546,97 @@
           <a:lstStyle/>
           <a:p>
             <a:pPr>
-              <a:defRPr sz="1400" b="1">
-                <a:solidFill>
-                  <a:srgbClr val="111827"/>
-                </a:solidFill>
-                <a:latin typeface="Arial"/>
-              </a:defRPr>
-            </a:pPr>
-            <a:r>
-              <a:t>1  Research Approach</a:t>
+              <a:spcAft>
+                <a:spcPts val="200"/>
+              </a:spcAft>
+            </a:pPr>
+            <a:r>
+              <a:rPr b="1" sz="1100">
+                <a:solidFill>
+                  <a:srgbClr val="003366"/>
+                </a:solidFill>
+                <a:latin typeface="Arial"/>
+              </a:rPr>
+              <a:t>•  National Failure Crisis: </a:t>
+            </a:r>
+            <a:r>
+              <a:rPr sz="1050">
+                <a:solidFill>
+                  <a:srgbClr val="374151"/>
+                </a:solidFill>
+                <a:latin typeface="Arial"/>
+              </a:rPr>
+              <a:t>In 2080-81 SEE, 79,271 students (15.42%) were marked Non-Graded (NG) in Science &amp; Technology—the highest deficit subject in Nepal (MoEST, 2024).</a:t>
             </a:r>
           </a:p>
           <a:p>
             <a:pPr>
-              <a:spcBef>
+              <a:spcAft>
                 <a:spcPts val="200"/>
-              </a:spcBef>
-              <a:defRPr sz="1100">
+              </a:spcAft>
+            </a:pPr>
+            <a:r>
+              <a:rPr b="1" sz="1100">
+                <a:solidFill>
+                  <a:srgbClr val="003366"/>
+                </a:solidFill>
+                <a:latin typeface="Arial"/>
+              </a:rPr>
+              <a:t>•  The AI 'Cognitive Crutch' Hazard: </a:t>
+            </a:r>
+            <a:r>
+              <a:rPr sz="1050">
                 <a:solidFill>
                   <a:srgbClr val="374151"/>
                 </a:solidFill>
                 <a:latin typeface="Arial"/>
-              </a:defRPr>
-            </a:pPr>
-            <a:r>
-              <a:t>Design Science Research (DSR; Peffers et al., 2007): 6-stage iterative cycle to design, build, test, and evaluate the artifact.</a:t>
-            </a:r>
-          </a:p>
-        </p:txBody>
-      </p:sp>
-      <p:sp>
-        <p:nvSpPr>
-          <p:cNvPr id="18" name="Rounded Rectangle 17"/>
+              </a:rPr>
+              <a:t>Commercial chatbots (GPT-4o) act as unearned answer dispensers (88% answer dumps), short-circuiting metacognition and inducing cognitive atrophy (Bastani et al., 2025).</a:t>
+            </a:r>
+          </a:p>
+          <a:p>
+            <a:pPr>
+              <a:spcAft>
+                <a:spcPts val="200"/>
+              </a:spcAft>
+            </a:pPr>
+            <a:r>
+              <a:rPr b="1" sz="1100">
+                <a:solidFill>
+                  <a:srgbClr val="003366"/>
+                </a:solidFill>
+                <a:latin typeface="Arial"/>
+              </a:rPr>
+              <a:t>•  Socio-Economic &amp; Rural Divide: </a:t>
+            </a:r>
+            <a:r>
+              <a:rPr sz="1050">
+                <a:solidFill>
+                  <a:srgbClr val="374151"/>
+                </a:solidFill>
+                <a:latin typeface="Arial"/>
+              </a:rPr>
+              <a:t>Private tutoring costs NPR 2,000–5,000/mo ($15–$40), unaffordable for rural families. Rural schools face 50+:1 pupil-teacher ratios and limited internet infrastructure.</a:t>
+            </a:r>
+          </a:p>
+        </p:txBody>
+      </p:sp>
+      <p:sp>
+        <p:nvSpPr>
+          <p:cNvPr id="12" name="Rounded Rectangle 11"/>
           <p:cNvSpPr/>
           <p:nvPr/>
         </p:nvSpPr>
         <p:spPr>
           <a:xfrm>
-            <a:off x="12655296" y="3977639"/>
-            <a:ext cx="3886200" cy="1051560"/>
+            <a:off x="731520" y="5440680"/>
+            <a:ext cx="7406640" cy="1143000"/>
           </a:xfrm>
           <a:prstGeom prst="roundRect">
             <a:avLst/>
           </a:prstGeom>
           <a:solidFill>
-            <a:srgbClr val="F9FAFB"/>
+            <a:srgbClr val="FFFFFF"/>
           </a:solidFill>
           <a:ln w="19050">
             <a:solidFill>
@@ -4084,14 +3668,49 @@
       </p:sp>
       <p:sp>
         <p:nvSpPr>
-          <p:cNvPr id="19" name="TextBox 18"/>
+          <p:cNvPr id="13" name="TextBox 12"/>
           <p:cNvSpPr txBox="1"/>
           <p:nvPr/>
         </p:nvSpPr>
         <p:spPr>
           <a:xfrm>
-            <a:off x="12765024" y="4069079"/>
-            <a:ext cx="3666744" cy="868680"/>
+            <a:off x="868680" y="5495544"/>
+            <a:ext cx="7132320" cy="274320"/>
+          </a:xfrm>
+          <a:prstGeom prst="rect">
+            <a:avLst/>
+          </a:prstGeom>
+          <a:noFill/>
+        </p:spPr>
+        <p:txBody>
+          <a:bodyPr wrap="none">
+            <a:spAutoFit/>
+          </a:bodyPr>
+          <a:lstStyle/>
+          <a:p>
+            <a:pPr>
+              <a:defRPr sz="1600" b="1">
+                <a:solidFill>
+                  <a:srgbClr val="111827"/>
+                </a:solidFill>
+              </a:defRPr>
+            </a:pPr>
+            <a:r>
+              <a:t>Identified Research Gap</a:t>
+            </a:r>
+          </a:p>
+        </p:txBody>
+      </p:sp>
+      <p:sp>
+        <p:nvSpPr>
+          <p:cNvPr id="14" name="TextBox 13"/>
+          <p:cNvSpPr txBox="1"/>
+          <p:nvPr/>
+        </p:nvSpPr>
+        <p:spPr>
+          <a:xfrm>
+            <a:off x="868680" y="5815584"/>
+            <a:ext cx="7132320" cy="731520"/>
           </a:xfrm>
           <a:prstGeom prst="rect">
             <a:avLst/>
@@ -4105,23 +3724,7 @@
           <a:lstStyle/>
           <a:p>
             <a:pPr>
-              <a:defRPr sz="1400" b="1">
-                <a:solidFill>
-                  <a:srgbClr val="111827"/>
-                </a:solidFill>
-                <a:latin typeface="Arial"/>
-              </a:defRPr>
-            </a:pPr>
-            <a:r>
-              <a:t>2  Ingestion &amp; Hybrid RAG</a:t>
-            </a:r>
-          </a:p>
-          <a:p>
-            <a:pPr>
-              <a:spcBef>
-                <a:spcPts val="200"/>
-              </a:spcBef>
-              <a:defRPr sz="1100">
+              <a:defRPr sz="1050">
                 <a:solidFill>
                   <a:srgbClr val="374151"/>
                 </a:solidFill>
@@ -4129,27 +3732,27 @@
               </a:defRPr>
             </a:pPr>
             <a:r>
-              <a:t>17 digital CDC volumes, OCR filter, regex boilerplate cleaning, 768d nomic-embed-text vectors in Chroma DB + lexical reranking.</a:t>
-            </a:r>
-          </a:p>
-        </p:txBody>
-      </p:sp>
-      <p:sp>
-        <p:nvSpPr>
-          <p:cNvPr id="20" name="Rounded Rectangle 19"/>
+              <a:t>Existing educational AI tools either act as didactic answer dispensers without national curriculum grounding, or rely on rigid rule-based ITS without conversational fluidity. No prior work provides open-weight Socratic dialogue models governed by deterministic turn gating combined with dynamic concept mastery tracking for South Asian national secondary curricula.</a:t>
+            </a:r>
+          </a:p>
+        </p:txBody>
+      </p:sp>
+      <p:sp>
+        <p:nvSpPr>
+          <p:cNvPr id="15" name="Rounded Rectangle 14"/>
           <p:cNvSpPr/>
           <p:nvPr/>
         </p:nvSpPr>
         <p:spPr>
           <a:xfrm>
-            <a:off x="16760951" y="3977639"/>
-            <a:ext cx="3886200" cy="1051560"/>
+            <a:off x="731520" y="6693408"/>
+            <a:ext cx="7406640" cy="2971800"/>
           </a:xfrm>
           <a:prstGeom prst="roundRect">
             <a:avLst/>
           </a:prstGeom>
           <a:solidFill>
-            <a:srgbClr val="F9FAFB"/>
+            <a:srgbClr val="FFFFFF"/>
           </a:solidFill>
           <a:ln w="19050">
             <a:solidFill>
@@ -4181,14 +3784,49 @@
       </p:sp>
       <p:sp>
         <p:nvSpPr>
-          <p:cNvPr id="21" name="TextBox 20"/>
+          <p:cNvPr id="16" name="TextBox 15"/>
           <p:cNvSpPr txBox="1"/>
           <p:nvPr/>
         </p:nvSpPr>
         <p:spPr>
           <a:xfrm>
-            <a:off x="16870680" y="4069079"/>
-            <a:ext cx="3666744" cy="868680"/>
+            <a:off x="868680" y="6748272"/>
+            <a:ext cx="7132320" cy="274320"/>
+          </a:xfrm>
+          <a:prstGeom prst="rect">
+            <a:avLst/>
+          </a:prstGeom>
+          <a:noFill/>
+        </p:spPr>
+        <p:txBody>
+          <a:bodyPr wrap="none">
+            <a:spAutoFit/>
+          </a:bodyPr>
+          <a:lstStyle/>
+          <a:p>
+            <a:pPr>
+              <a:defRPr sz="1600" b="1">
+                <a:solidFill>
+                  <a:srgbClr val="111827"/>
+                </a:solidFill>
+              </a:defRPr>
+            </a:pPr>
+            <a:r>
+              <a:t>Aim, Objectives &amp; Research Questions</a:t>
+            </a:r>
+          </a:p>
+        </p:txBody>
+      </p:sp>
+      <p:sp>
+        <p:nvSpPr>
+          <p:cNvPr id="17" name="TextBox 16"/>
+          <p:cNvSpPr txBox="1"/>
+          <p:nvPr/>
+        </p:nvSpPr>
+        <p:spPr>
+          <a:xfrm>
+            <a:off x="868680" y="7077456"/>
+            <a:ext cx="7132320" cy="2514600"/>
           </a:xfrm>
           <a:prstGeom prst="rect">
             <a:avLst/>
@@ -4202,7 +3840,10 @@
           <a:lstStyle/>
           <a:p>
             <a:pPr>
-              <a:defRPr sz="1400" b="1">
+              <a:spcAft>
+                <a:spcPts val="200"/>
+              </a:spcAft>
+              <a:defRPr sz="1050" b="1">
                 <a:solidFill>
                   <a:srgbClr val="111827"/>
                 </a:solidFill>
@@ -4210,15 +3851,32 @@
               </a:defRPr>
             </a:pPr>
             <a:r>
-              <a:t>3  Socratic Turn Policy</a:t>
+              <a:t>Research Aim: To design, implement, and empirically pilot Clariq—an AI-powered Socratic science tutor delivering curriculum-grounded dialogue, dynamically tracking mastery across a 135-node Knowledge Graph, and evaluating its pedagogical feasibility.</a:t>
             </a:r>
           </a:p>
           <a:p>
             <a:pPr>
-              <a:spcBef>
+              <a:spcAft>
                 <a:spcPts val="200"/>
-              </a:spcBef>
-              <a:defRPr sz="1100">
+              </a:spcAft>
+              <a:defRPr sz="1019" b="1">
+                <a:solidFill>
+                  <a:srgbClr val="003366"/>
+                </a:solidFill>
+                <a:latin typeface="Arial"/>
+              </a:defRPr>
+            </a:pPr>
+            <a:r>
+              <a:t>• RQ1 (Dialogue Restraint): Can open-weight LLMs, constrained by turn policies and RAG, sustain multi-turn inquiry without leaking direct answers?</a:t>
+            </a:r>
+            <a:br/>
+            <a:r>
+              <a:t>• RQ2 (Mastery Telemetry): Can conversational turns yield reliable concept mastery telemetry across an adaptive knowledge graph to flag struggling students?</a:t>
+            </a:r>
+          </a:p>
+          <a:p>
+            <a:pPr>
+              <a:defRPr sz="919">
                 <a:solidFill>
                   <a:srgbClr val="374151"/>
                 </a:solidFill>
@@ -4226,27 +3884,67 @@
               </a:defRPr>
             </a:pPr>
             <a:r>
-              <a:t>turn_policy.py: intent routing, terminal '?' gating, definitional assertion interception, and scaffolding counter-question override.</a:t>
-            </a:r>
-          </a:p>
-        </p:txBody>
-      </p:sp>
-      <p:sp>
-        <p:nvSpPr>
-          <p:cNvPr id="22" name="Rounded Rectangle 21"/>
+              <a:t>Itemized Research Targets:</a:t>
+            </a:r>
+            <a:br/>
+            <a:r>
+              <a:t>1. Ingest official CDC Class 10 science textbooks into Chroma vector DB</a:t>
+            </a:r>
+            <a:br/>
+            <a:r>
+              <a:t>2. Implement hybrid RAG with lexical candidate reranking (P@3 &gt;= 0.85)</a:t>
+            </a:r>
+            <a:br/>
+            <a:r>
+              <a:t>3. Enforce 5-stage turn policy (turn_policy.py) to suppress answer leakage</a:t>
+            </a:r>
+            <a:br/>
+            <a:r>
+              <a:t>4. Fine-tune open-weight Socratic dialogue model on dual T4 GPUs</a:t>
+            </a:r>
+            <a:br/>
+            <a:r>
+              <a:t>5. Eliminate script collapse via weight merging (Qwen2.5-7B Merged SFT)</a:t>
+            </a:r>
+            <a:br/>
+            <a:r>
+              <a:t>6. Construct 135-node directed knowledge graph across Physics, Chem, Bio</a:t>
+            </a:r>
+            <a:br/>
+            <a:r>
+              <a:t>7. Formulate token-overlap scoring with coherence and rote-copy penalties</a:t>
+            </a:r>
+            <a:br/>
+            <a:r>
+              <a:t>8. Implement Exponential Moving Average (EWMA) mastery updating</a:t>
+            </a:r>
+            <a:br/>
+            <a:r>
+              <a:t>9. Engineer teacher desk with real-time 3-turn struggle diagnostic flags</a:t>
+            </a:r>
+            <a:br/>
+            <a:r>
+              <a:t>10. Conduct controlled empirical pilot user study (N=20) vs. textbook baseline</a:t>
+            </a:r>
+          </a:p>
+        </p:txBody>
+      </p:sp>
+      <p:sp>
+        <p:nvSpPr>
+          <p:cNvPr id="18" name="Rounded Rectangle 17"/>
           <p:cNvSpPr/>
           <p:nvPr/>
         </p:nvSpPr>
         <p:spPr>
           <a:xfrm>
-            <a:off x="8549640" y="5175503"/>
-            <a:ext cx="3886200" cy="1051560"/>
+            <a:off x="731520" y="9784080"/>
+            <a:ext cx="7406640" cy="3246120"/>
           </a:xfrm>
           <a:prstGeom prst="roundRect">
             <a:avLst/>
           </a:prstGeom>
           <a:solidFill>
-            <a:srgbClr val="F9FAFB"/>
+            <a:srgbClr val="FFFFFF"/>
           </a:solidFill>
           <a:ln w="19050">
             <a:solidFill>
@@ -4278,14 +3976,49 @@
       </p:sp>
       <p:sp>
         <p:nvSpPr>
-          <p:cNvPr id="23" name="TextBox 22"/>
+          <p:cNvPr id="19" name="TextBox 18"/>
           <p:cNvSpPr txBox="1"/>
           <p:nvPr/>
         </p:nvSpPr>
         <p:spPr>
           <a:xfrm>
-            <a:off x="8659367" y="5266943"/>
-            <a:ext cx="3666744" cy="868680"/>
+            <a:off x="868680" y="9857232"/>
+            <a:ext cx="7132320" cy="292608"/>
+          </a:xfrm>
+          <a:prstGeom prst="rect">
+            <a:avLst/>
+          </a:prstGeom>
+          <a:noFill/>
+        </p:spPr>
+        <p:txBody>
+          <a:bodyPr wrap="none">
+            <a:spAutoFit/>
+          </a:bodyPr>
+          <a:lstStyle/>
+          <a:p>
+            <a:pPr>
+              <a:defRPr sz="1550" b="1">
+                <a:solidFill>
+                  <a:srgbClr val="111827"/>
+                </a:solidFill>
+              </a:defRPr>
+            </a:pPr>
+            <a:r>
+              <a:t>Curriculum Knowledge Base, Dataset &amp; Tech Stack</a:t>
+            </a:r>
+          </a:p>
+        </p:txBody>
+      </p:sp>
+      <p:sp>
+        <p:nvSpPr>
+          <p:cNvPr id="20" name="TextBox 19"/>
+          <p:cNvSpPr txBox="1"/>
+          <p:nvPr/>
+        </p:nvSpPr>
+        <p:spPr>
+          <a:xfrm>
+            <a:off x="868680" y="10204704"/>
+            <a:ext cx="7132320" cy="2743200"/>
           </a:xfrm>
           <a:prstGeom prst="rect">
             <a:avLst/>
@@ -4299,7 +4032,130 @@
           <a:lstStyle/>
           <a:p>
             <a:pPr>
-              <a:defRPr sz="1400" b="1">
+              <a:spcAft>
+                <a:spcPts val="250"/>
+              </a:spcAft>
+            </a:pPr>
+            <a:r>
+              <a:rPr b="1" sz="1050">
+                <a:solidFill>
+                  <a:srgbClr val="003366"/>
+                </a:solidFill>
+                <a:latin typeface="Arial"/>
+              </a:rPr>
+              <a:t>•  135 Curriculum Concept Nodes: </a:t>
+            </a:r>
+            <a:r>
+              <a:rPr sz="1000">
+                <a:solidFill>
+                  <a:srgbClr val="374151"/>
+                </a:solidFill>
+                <a:latin typeface="Arial"/>
+              </a:rPr>
+              <a:t>Physics (45 nodes: Force, Gravity, Pressure, Electricity, Heat); Chemistry (50 nodes: Reactions, Periodic Table, Acid-Base-Salt, Metals); Biology (40 nodes: Cells, Heredity, Circulation, Ecosystems).</a:t>
+            </a:r>
+          </a:p>
+          <a:p>
+            <a:pPr>
+              <a:spcAft>
+                <a:spcPts val="250"/>
+              </a:spcAft>
+            </a:pPr>
+            <a:r>
+              <a:rPr b="1" sz="1050">
+                <a:solidFill>
+                  <a:srgbClr val="003366"/>
+                </a:solidFill>
+                <a:latin typeface="Arial"/>
+              </a:rPr>
+              <a:t>•  17 CDC Textbooks (Curriculum RAG): </a:t>
+            </a:r>
+            <a:r>
+              <a:rPr sz="1000">
+                <a:solidFill>
+                  <a:srgbClr val="374151"/>
+                </a:solidFill>
+                <a:latin typeface="Arial"/>
+              </a:rPr>
+              <a:t>Official national curriculum text volumes digitized, cleaned with regex boilerplate stripping (&gt;15% page recurrence), partitioned into 1,200-char chunks (200 overlap), indexed in Chroma DB (768d vectors).</a:t>
+            </a:r>
+          </a:p>
+          <a:p>
+            <a:pPr>
+              <a:spcAft>
+                <a:spcPts val="250"/>
+              </a:spcAft>
+            </a:pPr>
+            <a:r>
+              <a:rPr b="1" sz="1050">
+                <a:solidFill>
+                  <a:srgbClr val="003366"/>
+                </a:solidFill>
+                <a:latin typeface="Arial"/>
+              </a:rPr>
+              <a:t>•  Socratic Dialogue Corpus (606 Dialogues): </a:t>
+            </a:r>
+            <a:r>
+              <a:rPr sz="1000">
+                <a:solidFill>
+                  <a:srgbClr val="374151"/>
+                </a:solidFill>
+                <a:latin typeface="Arial"/>
+              </a:rPr>
+              <a:t>4,628 multi-turn interactions spanning 5 pedagogical categories: Direct Conceptual, Misconceptions, Stuck/Confused, Topic Switches, and Ambiguous Probes.</a:t>
+            </a:r>
+          </a:p>
+          <a:p>
+            <a:pPr>
+              <a:spcAft>
+                <a:spcPts val="250"/>
+              </a:spcAft>
+            </a:pPr>
+            <a:r>
+              <a:rPr b="1" sz="1050">
+                <a:solidFill>
+                  <a:srgbClr val="003366"/>
+                </a:solidFill>
+                <a:latin typeface="Arial"/>
+              </a:rPr>
+              <a:t>•  Experimental Tech Stack: </a:t>
+            </a:r>
+            <a:r>
+              <a:rPr sz="1000">
+                <a:solidFill>
+                  <a:srgbClr val="374151"/>
+                </a:solidFill>
+                <a:latin typeface="Arial"/>
+              </a:rPr>
+              <a:t>Qwen2.5-7B Merged SFT, PyTorch, vLLM PagedAttention on RunPod GPU, FastAPI gateway, Chroma DB, React 18, Vite, Tailwind CSS, Expo (React Native).</a:t>
+            </a:r>
+          </a:p>
+        </p:txBody>
+      </p:sp>
+      <p:sp>
+        <p:nvSpPr>
+          <p:cNvPr id="21" name="TextBox 20"/>
+          <p:cNvSpPr txBox="1"/>
+          <p:nvPr/>
+        </p:nvSpPr>
+        <p:spPr>
+          <a:xfrm>
+            <a:off x="8549640" y="3218688"/>
+            <a:ext cx="12097512" cy="365760"/>
+          </a:xfrm>
+          <a:prstGeom prst="rect">
+            <a:avLst/>
+          </a:prstGeom>
+          <a:noFill/>
+        </p:spPr>
+        <p:txBody>
+          <a:bodyPr wrap="square" lIns="0" tIns="0" rIns="0" bIns="0">
+            <a:spAutoFit/>
+          </a:bodyPr>
+          <a:lstStyle/>
+          <a:p>
+            <a:pPr>
+              <a:defRPr sz="2000" b="1">
                 <a:solidFill>
                   <a:srgbClr val="111827"/>
                 </a:solidFill>
@@ -4307,37 +4163,21 @@
               </a:defRPr>
             </a:pPr>
             <a:r>
-              <a:t>4  Tutor LLM Fine-Tuning</a:t>
-            </a:r>
-          </a:p>
-          <a:p>
-            <a:pPr>
-              <a:spcBef>
-                <a:spcPts val="200"/>
-              </a:spcBef>
-              <a:defRPr sz="1100">
-                <a:solidFill>
-                  <a:srgbClr val="374151"/>
-                </a:solidFill>
-                <a:latin typeface="Arial"/>
-              </a:defRPr>
-            </a:pPr>
-            <a:r>
-              <a:t>Qwen2.5-7B SFT LoRA on 606 dialogues (4,628 turns); merged weights via merge_and_unload deployed on RunPod Serverless vLLM.</a:t>
-            </a:r>
-          </a:p>
-        </p:txBody>
-      </p:sp>
-      <p:sp>
-        <p:nvSpPr>
-          <p:cNvPr id="24" name="Rounded Rectangle 23"/>
+              <a:t>Research Methodology &amp; Engineering Framework</a:t>
+            </a:r>
+          </a:p>
+        </p:txBody>
+      </p:sp>
+      <p:sp>
+        <p:nvSpPr>
+          <p:cNvPr id="22" name="Rounded Rectangle 21"/>
           <p:cNvSpPr/>
           <p:nvPr/>
         </p:nvSpPr>
         <p:spPr>
           <a:xfrm>
-            <a:off x="12655296" y="5175503"/>
-            <a:ext cx="3886200" cy="1051560"/>
+            <a:off x="8549640" y="3566160"/>
+            <a:ext cx="3886200" cy="777240"/>
           </a:xfrm>
           <a:prstGeom prst="roundRect">
             <a:avLst/>
@@ -4375,14 +4215,14 @@
       </p:sp>
       <p:sp>
         <p:nvSpPr>
-          <p:cNvPr id="25" name="TextBox 24"/>
+          <p:cNvPr id="23" name="TextBox 22"/>
           <p:cNvSpPr txBox="1"/>
           <p:nvPr/>
         </p:nvSpPr>
         <p:spPr>
           <a:xfrm>
-            <a:off x="12765024" y="5266943"/>
-            <a:ext cx="3666744" cy="868680"/>
+            <a:off x="8641080" y="3611879"/>
+            <a:ext cx="3703320" cy="685800"/>
           </a:xfrm>
           <a:prstGeom prst="rect">
             <a:avLst/>
@@ -4396,7 +4236,7 @@
           <a:lstStyle/>
           <a:p>
             <a:pPr>
-              <a:defRPr sz="1400" b="1">
+              <a:defRPr sz="1250" b="1">
                 <a:solidFill>
                   <a:srgbClr val="111827"/>
                 </a:solidFill>
@@ -4404,15 +4244,15 @@
               </a:defRPr>
             </a:pPr>
             <a:r>
-              <a:t>5  Adaptive Knowledge Graph</a:t>
+              <a:t>1. Design Science Research</a:t>
             </a:r>
           </a:p>
           <a:p>
             <a:pPr>
               <a:spcBef>
-                <a:spcPts val="200"/>
+                <a:spcPts val="100"/>
               </a:spcBef>
-              <a:defRPr sz="1100">
+              <a:defRPr sz="950">
                 <a:solidFill>
                   <a:srgbClr val="374151"/>
                 </a:solidFill>
@@ -4420,21 +4260,21 @@
               </a:defRPr>
             </a:pPr>
             <a:r>
-              <a:t>135 concept nodes, 99 prerequisite edges, token-overlap scoring with coherence penalty, and EWMA mastery tracking (α = 0.25).</a:t>
-            </a:r>
-          </a:p>
-        </p:txBody>
-      </p:sp>
-      <p:sp>
-        <p:nvSpPr>
-          <p:cNvPr id="26" name="Rounded Rectangle 25"/>
+              <a:t>Six DSR iterative stages: problem identification, objective definition, design/dev, demonstration, evaluation, dissemination (Peffers et al., 2007).</a:t>
+            </a:r>
+          </a:p>
+        </p:txBody>
+      </p:sp>
+      <p:sp>
+        <p:nvSpPr>
+          <p:cNvPr id="24" name="Rounded Rectangle 23"/>
           <p:cNvSpPr/>
           <p:nvPr/>
         </p:nvSpPr>
         <p:spPr>
           <a:xfrm>
-            <a:off x="16760951" y="5175503"/>
-            <a:ext cx="3886200" cy="1051560"/>
+            <a:off x="12655296" y="3566160"/>
+            <a:ext cx="3886200" cy="777240"/>
           </a:xfrm>
           <a:prstGeom prst="roundRect">
             <a:avLst/>
@@ -4472,14 +4312,14 @@
       </p:sp>
       <p:sp>
         <p:nvSpPr>
-          <p:cNvPr id="27" name="TextBox 26"/>
+          <p:cNvPr id="25" name="TextBox 24"/>
           <p:cNvSpPr txBox="1"/>
           <p:nvPr/>
         </p:nvSpPr>
         <p:spPr>
           <a:xfrm>
-            <a:off x="16870680" y="5266943"/>
-            <a:ext cx="3666744" cy="868680"/>
+            <a:off x="12746736" y="3611879"/>
+            <a:ext cx="3703320" cy="685800"/>
           </a:xfrm>
           <a:prstGeom prst="rect">
             <a:avLst/>
@@ -4493,7 +4333,7 @@
           <a:lstStyle/>
           <a:p>
             <a:pPr>
-              <a:defRPr sz="1400" b="1">
+              <a:defRPr sz="1250" b="1">
                 <a:solidFill>
                   <a:srgbClr val="111827"/>
                 </a:solidFill>
@@ -4501,15 +4341,15 @@
               </a:defRPr>
             </a:pPr>
             <a:r>
-              <a:t>6  Client Ecosystem</a:t>
+              <a:t>2. Hybrid Retrieval (RAG)</a:t>
             </a:r>
           </a:p>
           <a:p>
             <a:pPr>
               <a:spcBef>
-                <a:spcPts val="200"/>
+                <a:spcPts val="100"/>
               </a:spcBef>
-              <a:defRPr sz="1100">
+              <a:defRPr sz="950">
                 <a:solidFill>
                   <a:srgbClr val="374151"/>
                 </a:solidFill>
@@ -4517,87 +4357,27 @@
               </a:defRPr>
             </a:pPr>
             <a:r>
-              <a:t>React 18 / Vite Nebular UI desktop tutoring bench, Teacher Diagnostic Desk for class-wide heatmaps, and Expo React Native mobile app.</a:t>
-            </a:r>
-          </a:p>
-        </p:txBody>
-      </p:sp>
-      <p:sp>
-        <p:nvSpPr>
-          <p:cNvPr id="28" name="TextBox 27"/>
-          <p:cNvSpPr txBox="1"/>
-          <p:nvPr/>
-        </p:nvSpPr>
-        <p:spPr>
-          <a:xfrm>
-            <a:off x="8549640" y="6400800"/>
-            <a:ext cx="12097512" cy="502920"/>
-          </a:xfrm>
-          <a:prstGeom prst="rect">
-            <a:avLst/>
-          </a:prstGeom>
-          <a:noFill/>
-        </p:spPr>
-        <p:txBody>
-          <a:bodyPr wrap="square" lIns="0" tIns="0" rIns="0" bIns="0">
-            <a:spAutoFit/>
-          </a:bodyPr>
-          <a:lstStyle/>
-          <a:p>
-            <a:pPr>
-              <a:defRPr sz="2300" b="1">
-                <a:solidFill>
-                  <a:srgbClr val="111827"/>
-                </a:solidFill>
-                <a:latin typeface="Arial"/>
-              </a:defRPr>
-            </a:pPr>
-            <a:r>
-              <a:t>Clariq Six-Layer System Architecture &amp; Interaction Workflow</a:t>
-            </a:r>
-          </a:p>
-        </p:txBody>
-      </p:sp>
-      <p:pic>
-        <p:nvPicPr>
-          <p:cNvPr id="29" name="Picture 28" descr="fig_system_architecture.png"/>
-          <p:cNvPicPr>
-            <a:picLocks noChangeAspect="1"/>
-          </p:cNvPicPr>
-          <p:nvPr/>
-        </p:nvPicPr>
-        <p:blipFill>
-          <a:blip r:embed="rId3"/>
-          <a:stretch>
-            <a:fillRect/>
-          </a:stretch>
-        </p:blipFill>
-        <p:spPr>
-          <a:xfrm>
-            <a:off x="8549640" y="6858000"/>
-            <a:ext cx="12097512" cy="8257970"/>
-          </a:xfrm>
-          <a:prstGeom prst="rect">
-            <a:avLst/>
-          </a:prstGeom>
-        </p:spPr>
-      </p:pic>
-      <p:sp>
-        <p:nvSpPr>
-          <p:cNvPr id="30" name="Rounded Rectangle 29"/>
+              <a:t>Domain-sanitized CDC corpus (17 textbooks) embedded via nomic-embed-text (768d) in Chroma DB with lexical candidate reranking for curriculum grounding.</a:t>
+            </a:r>
+          </a:p>
+        </p:txBody>
+      </p:sp>
+      <p:sp>
+        <p:nvSpPr>
+          <p:cNvPr id="26" name="Rounded Rectangle 25"/>
           <p:cNvSpPr/>
           <p:nvPr/>
         </p:nvSpPr>
         <p:spPr>
           <a:xfrm>
-            <a:off x="731520" y="10835640"/>
-            <a:ext cx="12070080" cy="1920240"/>
+            <a:off x="16760951" y="3566160"/>
+            <a:ext cx="3886200" cy="777240"/>
           </a:xfrm>
           <a:prstGeom prst="roundRect">
             <a:avLst/>
           </a:prstGeom>
           <a:solidFill>
-            <a:srgbClr val="FFFFFF"/>
+            <a:srgbClr val="F9FAFB"/>
           </a:solidFill>
           <a:ln w="19050">
             <a:solidFill>
@@ -4629,14 +4409,14 @@
       </p:sp>
       <p:sp>
         <p:nvSpPr>
-          <p:cNvPr id="31" name="TextBox 30"/>
+          <p:cNvPr id="27" name="TextBox 26"/>
           <p:cNvSpPr txBox="1"/>
           <p:nvPr/>
         </p:nvSpPr>
         <p:spPr>
           <a:xfrm>
-            <a:off x="960120" y="10927080"/>
-            <a:ext cx="11612880" cy="1737360"/>
+            <a:off x="16852392" y="3611879"/>
+            <a:ext cx="3703320" cy="685800"/>
           </a:xfrm>
           <a:prstGeom prst="rect">
             <a:avLst/>
@@ -4650,7 +4430,7 @@
           <a:lstStyle/>
           <a:p>
             <a:pPr>
-              <a:defRPr sz="1600" b="1">
+              <a:defRPr sz="1250" b="1">
                 <a:solidFill>
                   <a:srgbClr val="111827"/>
                 </a:solidFill>
@@ -4658,15 +4438,15 @@
               </a:defRPr>
             </a:pPr>
             <a:r>
-              <a:t>SEE Science Curriculum Concept Nodes (135 Nodes Across 3 Branches)</a:t>
+              <a:t>3. Turn Policy Gating</a:t>
             </a:r>
           </a:p>
           <a:p>
             <a:pPr>
               <a:spcBef>
-                <a:spcPts val="300"/>
+                <a:spcPts val="100"/>
               </a:spcBef>
-              <a:defRPr sz="1200">
+              <a:defRPr sz="950">
                 <a:solidFill>
                   <a:srgbClr val="374151"/>
                 </a:solidFill>
@@ -4674,51 +4454,27 @@
               </a:defRPr>
             </a:pPr>
             <a:r>
-              <a:t>•  Physics (45 Nodes): Force, Gravity, Pressure, Energy, Heat, Light, Current Electricity, Magnetism</a:t>
-            </a:r>
-            <a:br/>
-            <a:r>
-              <a:t>•  Chemistry (50 Nodes): Periodic Table, Chemical Reactions, Acid-Base-Salt, Metals, Hydrocarbons &amp; Derivatives</a:t>
-            </a:r>
-            <a:br/>
-            <a:r>
-              <a:t>•  Biology (40 Nodes): Cell Reproduction, Heredity, Nervous System, Blood Circulation, Ecosystems &amp; Balance</a:t>
-            </a:r>
-          </a:p>
-          <a:p>
-            <a:pPr>
-              <a:spcBef>
-                <a:spcPts val="300"/>
-              </a:spcBef>
-              <a:defRPr sz="1100">
-                <a:solidFill>
-                  <a:srgbClr val="6B7280"/>
-                </a:solidFill>
-                <a:latin typeface="Arial"/>
-              </a:defRPr>
-            </a:pPr>
-            <a:r>
-              <a:t>Curriculum Ingestion Hygiene: 17 official CDC textbooks cleaned with boilerplate regex stripping (&gt;15% page recurrence), 1200-char chunking with 200-char overlap, nomic-embed-text (768d) vectors indexed in Chroma DB.</a:t>
-            </a:r>
-          </a:p>
-        </p:txBody>
-      </p:sp>
-      <p:sp>
-        <p:nvSpPr>
-          <p:cNvPr id="32" name="Rounded Rectangle 31"/>
+              <a:t>turn_policy.py 5-stage deterministic state machine enforcing Socratic restraint, scaffolding inquiry probes, and suppressing direct factual answer disclosures.</a:t>
+            </a:r>
+          </a:p>
+        </p:txBody>
+      </p:sp>
+      <p:sp>
+        <p:nvSpPr>
+          <p:cNvPr id="28" name="Rounded Rectangle 27"/>
           <p:cNvSpPr/>
           <p:nvPr/>
         </p:nvSpPr>
         <p:spPr>
           <a:xfrm>
-            <a:off x="13021056" y="10835640"/>
-            <a:ext cx="7626096" cy="1920240"/>
+            <a:off x="8549640" y="4480560"/>
+            <a:ext cx="3886200" cy="777240"/>
           </a:xfrm>
           <a:prstGeom prst="roundRect">
             <a:avLst/>
           </a:prstGeom>
           <a:solidFill>
-            <a:srgbClr val="FFFFFF"/>
+            <a:srgbClr val="F9FAFB"/>
           </a:solidFill>
           <a:ln w="19050">
             <a:solidFill>
@@ -4750,14 +4506,14 @@
       </p:sp>
       <p:sp>
         <p:nvSpPr>
-          <p:cNvPr id="33" name="TextBox 32"/>
+          <p:cNvPr id="29" name="TextBox 28"/>
           <p:cNvSpPr txBox="1"/>
           <p:nvPr/>
         </p:nvSpPr>
         <p:spPr>
           <a:xfrm>
-            <a:off x="13213080" y="10927080"/>
-            <a:ext cx="7260336" cy="1737360"/>
+            <a:off x="8641080" y="4526280"/>
+            <a:ext cx="3703320" cy="685800"/>
           </a:xfrm>
           <a:prstGeom prst="rect">
             <a:avLst/>
@@ -4771,7 +4527,7 @@
           <a:lstStyle/>
           <a:p>
             <a:pPr>
-              <a:defRPr sz="1600" b="1">
+              <a:defRPr sz="1250" b="1">
                 <a:solidFill>
                   <a:srgbClr val="111827"/>
                 </a:solidFill>
@@ -4779,15 +4535,15 @@
               </a:defRPr>
             </a:pPr>
             <a:r>
-              <a:t>Socratic Dataset &amp; Experimental Tech Stack</a:t>
+              <a:t>4. SFT Socratic LLM</a:t>
             </a:r>
           </a:p>
           <a:p>
             <a:pPr>
               <a:spcBef>
-                <a:spcPts val="300"/>
+                <a:spcPts val="100"/>
               </a:spcBef>
-              <a:defRPr sz="1150">
+              <a:defRPr sz="950">
                 <a:solidFill>
                   <a:srgbClr val="374151"/>
                 </a:solidFill>
@@ -4795,71 +4551,27 @@
               </a:defRPr>
             </a:pPr>
             <a:r>
-              <a:t>•  Training Corpus: 606 curated dialogues (4,628 turns) covering Direct Conceptual, Misconceptions, Stuck/Confused, Topic Switches, and Ambiguous Probes.</a:t>
-            </a:r>
-            <a:br/>
-            <a:r>
-              <a:t>•  AI &amp; LLM Stack: Qwen2.5-7B-Instruct, PyTorch, Hugging Face PEFT, vLLM PagedAttention on RunPod Serverless GPU.</a:t>
-            </a:r>
-            <a:br/>
-            <a:r>
-              <a:t>•  App Stack: FastAPI, Chroma DB, React 18, Vite, Tailwind CSS, Expo (React Native).</a:t>
-            </a:r>
-          </a:p>
-        </p:txBody>
-      </p:sp>
-      <p:sp>
-        <p:nvSpPr>
-          <p:cNvPr id="34" name="TextBox 33"/>
-          <p:cNvSpPr txBox="1"/>
-          <p:nvPr/>
-        </p:nvSpPr>
-        <p:spPr>
-          <a:xfrm>
-            <a:off x="731520" y="12984480"/>
-            <a:ext cx="19921118" cy="502920"/>
-          </a:xfrm>
-          <a:prstGeom prst="rect">
-            <a:avLst/>
-          </a:prstGeom>
-          <a:noFill/>
-        </p:spPr>
-        <p:txBody>
-          <a:bodyPr wrap="square" lIns="0" tIns="0" rIns="0" bIns="0">
-            <a:spAutoFit/>
-          </a:bodyPr>
-          <a:lstStyle/>
-          <a:p>
-            <a:pPr>
-              <a:defRPr sz="2300" b="1">
-                <a:solidFill>
-                  <a:srgbClr val="111827"/>
-                </a:solidFill>
-                <a:latin typeface="Arial"/>
-              </a:defRPr>
-            </a:pPr>
-            <a:r>
-              <a:t>Client Ecosystem &amp; Visual User Interface Evidence</a:t>
-            </a:r>
-          </a:p>
-        </p:txBody>
-      </p:sp>
-      <p:sp>
-        <p:nvSpPr>
-          <p:cNvPr id="35" name="Rounded Rectangle 34"/>
+              <a:t>Qwen2.5-7B fine-tuned on 606 curriculum dialogues across 5 pedagogical categories on dual T4 GPUs with merged weights to eliminate script collapse.</a:t>
+            </a:r>
+          </a:p>
+        </p:txBody>
+      </p:sp>
+      <p:sp>
+        <p:nvSpPr>
+          <p:cNvPr id="30" name="Rounded Rectangle 29"/>
           <p:cNvSpPr/>
           <p:nvPr/>
         </p:nvSpPr>
         <p:spPr>
           <a:xfrm>
-            <a:off x="731520" y="13487400"/>
-            <a:ext cx="2697480" cy="4023360"/>
+            <a:off x="12655296" y="4480560"/>
+            <a:ext cx="3886200" cy="777240"/>
           </a:xfrm>
           <a:prstGeom prst="roundRect">
             <a:avLst/>
           </a:prstGeom>
           <a:solidFill>
-            <a:srgbClr val="FFFFFF"/>
+            <a:srgbClr val="F9FAFB"/>
           </a:solidFill>
           <a:ln w="19050">
             <a:solidFill>
@@ -4891,14 +4603,14 @@
       </p:sp>
       <p:sp>
         <p:nvSpPr>
-          <p:cNvPr id="36" name="TextBox 35"/>
+          <p:cNvPr id="31" name="TextBox 30"/>
           <p:cNvSpPr txBox="1"/>
           <p:nvPr/>
         </p:nvSpPr>
         <p:spPr>
           <a:xfrm>
-            <a:off x="804672" y="13560552"/>
-            <a:ext cx="2551176" cy="621792"/>
+            <a:off x="12746736" y="4526280"/>
+            <a:ext cx="3703320" cy="685800"/>
           </a:xfrm>
           <a:prstGeom prst="rect">
             <a:avLst/>
@@ -4911,8 +4623,8 @@
           </a:bodyPr>
           <a:lstStyle/>
           <a:p>
-            <a:pPr algn="ctr">
-              <a:defRPr sz="1150" b="1">
+            <a:pPr>
+              <a:defRPr sz="1250" b="1">
                 <a:solidFill>
                   <a:srgbClr val="111827"/>
                 </a:solidFill>
@@ -4920,55 +4632,43 @@
               </a:defRPr>
             </a:pPr>
             <a:r>
-              <a:t>Navigation &amp;</a:t>
-            </a:r>
-            <a:br/>
-            <a:r>
-              <a:t>Landing Portal</a:t>
-            </a:r>
-          </a:p>
-        </p:txBody>
-      </p:sp>
-      <p:pic>
-        <p:nvPicPr>
-          <p:cNvPr id="37" name="Picture 36" descr="fig_ui_landing.png"/>
-          <p:cNvPicPr>
-            <a:picLocks noChangeAspect="1"/>
-          </p:cNvPicPr>
-          <p:nvPr/>
-        </p:nvPicPr>
-        <p:blipFill>
-          <a:blip r:embed="rId4"/>
-          <a:stretch>
-            <a:fillRect/>
-          </a:stretch>
-        </p:blipFill>
-        <p:spPr>
-          <a:xfrm>
-            <a:off x="841248" y="14218920"/>
-            <a:ext cx="2478024" cy="1280151"/>
-          </a:xfrm>
-          <a:prstGeom prst="rect">
-            <a:avLst/>
-          </a:prstGeom>
-        </p:spPr>
-      </p:pic>
-      <p:sp>
-        <p:nvSpPr>
-          <p:cNvPr id="38" name="Rounded Rectangle 37"/>
+              <a:t>5. Knowledge Graph &amp; EWMA</a:t>
+            </a:r>
+          </a:p>
+          <a:p>
+            <a:pPr>
+              <a:spcBef>
+                <a:spcPts val="100"/>
+              </a:spcBef>
+              <a:defRPr sz="950">
+                <a:solidFill>
+                  <a:srgbClr val="374151"/>
+                </a:solidFill>
+                <a:latin typeface="Arial"/>
+              </a:defRPr>
+            </a:pPr>
+            <a:r>
+              <a:t>135 concept nodes (Physics, Chem, Bio). Real-time student response scoring (token overlap, copy penalty) and Exponential Moving Average telemetry.</a:t>
+            </a:r>
+          </a:p>
+        </p:txBody>
+      </p:sp>
+      <p:sp>
+        <p:nvSpPr>
+          <p:cNvPr id="32" name="Rounded Rectangle 31"/>
           <p:cNvSpPr/>
           <p:nvPr/>
         </p:nvSpPr>
         <p:spPr>
           <a:xfrm>
-            <a:off x="3593592" y="13487400"/>
-            <a:ext cx="2697480" cy="4023360"/>
+            <a:off x="16760951" y="4480560"/>
+            <a:ext cx="3886200" cy="777240"/>
           </a:xfrm>
           <a:prstGeom prst="roundRect">
             <a:avLst/>
           </a:prstGeom>
           <a:solidFill>
-            <a:srgbClr val="FFFFFF"/>
+            <a:srgbClr val="F9FAFB"/>
           </a:solidFill>
           <a:ln w="19050">
             <a:solidFill>
@@ -5000,14 +4700,14 @@
       </p:sp>
       <p:sp>
         <p:nvSpPr>
-          <p:cNvPr id="39" name="TextBox 38"/>
+          <p:cNvPr id="33" name="TextBox 32"/>
           <p:cNvSpPr txBox="1"/>
           <p:nvPr/>
         </p:nvSpPr>
         <p:spPr>
           <a:xfrm>
-            <a:off x="3666744" y="13560552"/>
-            <a:ext cx="2551176" cy="621792"/>
+            <a:off x="16852392" y="4526280"/>
+            <a:ext cx="3703320" cy="685800"/>
           </a:xfrm>
           <a:prstGeom prst="rect">
             <a:avLst/>
@@ -5020,8 +4720,8 @@
           </a:bodyPr>
           <a:lstStyle/>
           <a:p>
-            <a:pPr algn="ctr">
-              <a:defRPr sz="1150" b="1">
+            <a:pPr>
+              <a:defRPr sz="1250" b="1">
                 <a:solidFill>
                   <a:srgbClr val="111827"/>
                 </a:solidFill>
@@ -5029,49 +4729,73 @@
               </a:defRPr>
             </a:pPr>
             <a:r>
-              <a:t>Authentication &amp;</a:t>
-            </a:r>
-            <a:br/>
-            <a:r>
-              <a:t>Onboarding</a:t>
-            </a:r>
-          </a:p>
-        </p:txBody>
-      </p:sp>
-      <p:pic>
-        <p:nvPicPr>
-          <p:cNvPr id="40" name="Picture 39" descr="fig_ui_login.png"/>
-          <p:cNvPicPr>
-            <a:picLocks noChangeAspect="1"/>
-          </p:cNvPicPr>
+              <a:t>6. Client Ecosystem</a:t>
+            </a:r>
+          </a:p>
+          <a:p>
+            <a:pPr>
+              <a:spcBef>
+                <a:spcPts val="100"/>
+              </a:spcBef>
+              <a:defRPr sz="950">
+                <a:solidFill>
+                  <a:srgbClr val="374151"/>
+                </a:solidFill>
+                <a:latin typeface="Arial"/>
+              </a:defRPr>
+            </a:pPr>
+            <a:r>
+              <a:t>Cross-platform access via React 18 / Vite web application and Expo (React Native) mobile client; teacher diagnostic analytics desk with struggle flags.</a:t>
+            </a:r>
+          </a:p>
+        </p:txBody>
+      </p:sp>
+      <p:sp>
+        <p:nvSpPr>
+          <p:cNvPr id="34" name="TextBox 33"/>
+          <p:cNvSpPr txBox="1"/>
           <p:nvPr/>
-        </p:nvPicPr>
-        <p:blipFill>
-          <a:blip r:embed="rId5"/>
-          <a:stretch>
-            <a:fillRect/>
-          </a:stretch>
-        </p:blipFill>
-        <p:spPr>
-          <a:xfrm>
-            <a:off x="3703320" y="14218920"/>
-            <a:ext cx="2478024" cy="1280151"/>
+        </p:nvSpPr>
+        <p:spPr>
+          <a:xfrm>
+            <a:off x="8549640" y="5394960"/>
+            <a:ext cx="12097512" cy="365760"/>
           </a:xfrm>
           <a:prstGeom prst="rect">
             <a:avLst/>
           </a:prstGeom>
-        </p:spPr>
-      </p:pic>
-      <p:sp>
-        <p:nvSpPr>
-          <p:cNvPr id="41" name="Rounded Rectangle 40"/>
+          <a:noFill/>
+        </p:spPr>
+        <p:txBody>
+          <a:bodyPr wrap="square" lIns="0" tIns="0" rIns="0" bIns="0">
+            <a:spAutoFit/>
+          </a:bodyPr>
+          <a:lstStyle/>
+          <a:p>
+            <a:pPr>
+              <a:defRPr sz="2000" b="1">
+                <a:solidFill>
+                  <a:srgbClr val="111827"/>
+                </a:solidFill>
+                <a:latin typeface="Arial"/>
+              </a:defRPr>
+            </a:pPr>
+            <a:r>
+              <a:t>Clariq Six-Layer System Architecture &amp; Interaction Workflow</a:t>
+            </a:r>
+          </a:p>
+        </p:txBody>
+      </p:sp>
+      <p:sp>
+        <p:nvSpPr>
+          <p:cNvPr id="35" name="Rounded Rectangle 34"/>
           <p:cNvSpPr/>
           <p:nvPr/>
         </p:nvSpPr>
         <p:spPr>
           <a:xfrm>
-            <a:off x="6455664" y="13487400"/>
-            <a:ext cx="2697480" cy="4023360"/>
+            <a:off x="8549640" y="5760720"/>
+            <a:ext cx="12097512" cy="7269480"/>
           </a:xfrm>
           <a:prstGeom prst="roundRect">
             <a:avLst/>
@@ -5107,64 +4831,24 @@
           </a:p>
         </p:txBody>
       </p:sp>
-      <p:sp>
-        <p:nvSpPr>
-          <p:cNvPr id="42" name="TextBox 41"/>
-          <p:cNvSpPr txBox="1"/>
-          <p:nvPr/>
-        </p:nvSpPr>
-        <p:spPr>
-          <a:xfrm>
-            <a:off x="6528816" y="13560552"/>
-            <a:ext cx="2551176" cy="621792"/>
-          </a:xfrm>
-          <a:prstGeom prst="rect">
-            <a:avLst/>
-          </a:prstGeom>
-          <a:noFill/>
-        </p:spPr>
-        <p:txBody>
-          <a:bodyPr wrap="square" lIns="0" tIns="0" rIns="0" bIns="0">
-            <a:spAutoFit/>
-          </a:bodyPr>
-          <a:lstStyle/>
-          <a:p>
-            <a:pPr algn="ctr">
-              <a:defRPr sz="1150" b="1">
-                <a:solidFill>
-                  <a:srgbClr val="111827"/>
-                </a:solidFill>
-                <a:latin typeface="Arial"/>
-              </a:defRPr>
-            </a:pPr>
-            <a:r>
-              <a:t>Socratic Tutoring</a:t>
-            </a:r>
-            <a:br/>
-            <a:r>
-              <a:t>Bench (React 18)</a:t>
-            </a:r>
-          </a:p>
-        </p:txBody>
-      </p:sp>
       <p:pic>
         <p:nvPicPr>
-          <p:cNvPr id="43" name="Picture 42" descr="fig_ui_chat_desktop.png"/>
+          <p:cNvPr id="36" name="Picture 35" descr="fig_system_architecture.png"/>
           <p:cNvPicPr>
             <a:picLocks noChangeAspect="1"/>
           </p:cNvPicPr>
           <p:nvPr/>
         </p:nvPicPr>
         <p:blipFill>
-          <a:blip r:embed="rId6"/>
+          <a:blip r:embed="rId3"/>
           <a:stretch>
             <a:fillRect/>
           </a:stretch>
         </p:blipFill>
         <p:spPr>
           <a:xfrm>
-            <a:off x="6565392" y="14218920"/>
-            <a:ext cx="2478024" cy="1277731"/>
+            <a:off x="9336024" y="5806440"/>
+            <a:ext cx="10515600" cy="7178040"/>
           </a:xfrm>
           <a:prstGeom prst="rect">
             <a:avLst/>
@@ -5173,14 +4857,50 @@
       </p:pic>
       <p:sp>
         <p:nvSpPr>
-          <p:cNvPr id="44" name="Rounded Rectangle 43"/>
+          <p:cNvPr id="37" name="TextBox 36"/>
+          <p:cNvSpPr txBox="1"/>
+          <p:nvPr/>
+        </p:nvSpPr>
+        <p:spPr>
+          <a:xfrm>
+            <a:off x="731520" y="13213080"/>
+            <a:ext cx="19921118" cy="365760"/>
+          </a:xfrm>
+          <a:prstGeom prst="rect">
+            <a:avLst/>
+          </a:prstGeom>
+          <a:noFill/>
+        </p:spPr>
+        <p:txBody>
+          <a:bodyPr wrap="square" lIns="0" tIns="0" rIns="0" bIns="0">
+            <a:spAutoFit/>
+          </a:bodyPr>
+          <a:lstStyle/>
+          <a:p>
+            <a:pPr>
+              <a:defRPr sz="2000" b="1">
+                <a:solidFill>
+                  <a:srgbClr val="111827"/>
+                </a:solidFill>
+                <a:latin typeface="Arial"/>
+              </a:defRPr>
+            </a:pPr>
+            <a:r>
+              <a:t>Empirical Model Evaluation &amp; Adversarial Benchmark (100-Item Challenge Suite)</a:t>
+            </a:r>
+          </a:p>
+        </p:txBody>
+      </p:sp>
+      <p:sp>
+        <p:nvSpPr>
+          <p:cNvPr id="38" name="Rounded Rectangle 37"/>
           <p:cNvSpPr/>
           <p:nvPr/>
         </p:nvSpPr>
         <p:spPr>
           <a:xfrm>
-            <a:off x="9317736" y="13487400"/>
-            <a:ext cx="2697480" cy="4023360"/>
+            <a:off x="731520" y="13578840"/>
+            <a:ext cx="8686800" cy="4023360"/>
           </a:xfrm>
           <a:prstGeom prst="roundRect">
             <a:avLst/>
@@ -5216,64 +4936,24 @@
           </a:p>
         </p:txBody>
       </p:sp>
-      <p:sp>
-        <p:nvSpPr>
-          <p:cNvPr id="45" name="TextBox 44"/>
-          <p:cNvSpPr txBox="1"/>
-          <p:nvPr/>
-        </p:nvSpPr>
-        <p:spPr>
-          <a:xfrm>
-            <a:off x="9390888" y="13560552"/>
-            <a:ext cx="2551176" cy="621792"/>
-          </a:xfrm>
-          <a:prstGeom prst="rect">
-            <a:avLst/>
-          </a:prstGeom>
-          <a:noFill/>
-        </p:spPr>
-        <p:txBody>
-          <a:bodyPr wrap="square" lIns="0" tIns="0" rIns="0" bIns="0">
-            <a:spAutoFit/>
-          </a:bodyPr>
-          <a:lstStyle/>
-          <a:p>
-            <a:pPr algn="ctr">
-              <a:defRPr sz="1150" b="1">
-                <a:solidFill>
-                  <a:srgbClr val="111827"/>
-                </a:solidFill>
-                <a:latin typeface="Arial"/>
-              </a:defRPr>
-            </a:pPr>
-            <a:r>
-              <a:t>Scaffolding</a:t>
-            </a:r>
-            <a:br/>
-            <a:r>
-              <a:t>Dialogue Exchange</a:t>
-            </a:r>
-          </a:p>
-        </p:txBody>
-      </p:sp>
       <p:pic>
         <p:nvPicPr>
-          <p:cNvPr id="46" name="Picture 45" descr="fig_socratic_exchange.png"/>
+          <p:cNvPr id="39" name="Picture 38" descr="fig_model_smoke_comparison.png"/>
           <p:cNvPicPr>
             <a:picLocks noChangeAspect="1"/>
           </p:cNvPicPr>
           <p:nvPr/>
         </p:nvPicPr>
         <p:blipFill>
-          <a:blip r:embed="rId7"/>
+          <a:blip r:embed="rId4"/>
           <a:stretch>
             <a:fillRect/>
           </a:stretch>
         </p:blipFill>
         <p:spPr>
           <a:xfrm>
-            <a:off x="9427464" y="14218920"/>
-            <a:ext cx="2478024" cy="1892935"/>
+            <a:off x="1197864" y="13670280"/>
+            <a:ext cx="7754112" cy="3840480"/>
           </a:xfrm>
           <a:prstGeom prst="rect">
             <a:avLst/>
@@ -5282,14 +4962,14 @@
       </p:pic>
       <p:sp>
         <p:nvSpPr>
-          <p:cNvPr id="47" name="Rounded Rectangle 46"/>
+          <p:cNvPr id="40" name="Rounded Rectangle 39"/>
           <p:cNvSpPr/>
           <p:nvPr/>
         </p:nvSpPr>
         <p:spPr>
           <a:xfrm>
-            <a:off x="12179808" y="13487400"/>
-            <a:ext cx="2697480" cy="4023360"/>
+            <a:off x="9601200" y="13578840"/>
+            <a:ext cx="11045952" cy="4023360"/>
           </a:xfrm>
           <a:prstGeom prst="roundRect">
             <a:avLst/>
@@ -5327,14 +5007,14 @@
       </p:sp>
       <p:sp>
         <p:nvSpPr>
-          <p:cNvPr id="48" name="TextBox 47"/>
+          <p:cNvPr id="41" name="TextBox 40"/>
           <p:cNvSpPr txBox="1"/>
           <p:nvPr/>
         </p:nvSpPr>
         <p:spPr>
           <a:xfrm>
-            <a:off x="12252960" y="13560552"/>
-            <a:ext cx="2551176" cy="621792"/>
+            <a:off x="9829800" y="13670280"/>
+            <a:ext cx="10607040" cy="3840480"/>
           </a:xfrm>
           <a:prstGeom prst="rect">
             <a:avLst/>
@@ -5347,8 +5027,8 @@
           </a:bodyPr>
           <a:lstStyle/>
           <a:p>
-            <a:pPr algn="ctr">
-              <a:defRPr sz="1150" b="1">
+            <a:pPr>
+              <a:defRPr sz="1550" b="1">
                 <a:solidFill>
                   <a:srgbClr val="111827"/>
                 </a:solidFill>
@@ -5356,49 +5036,160 @@
               </a:defRPr>
             </a:pPr>
             <a:r>
-              <a:t>Teacher Desk</a:t>
-            </a:r>
-            <a:br/>
-            <a:r>
-              <a:t>Diagnostic Analytics</a:t>
-            </a:r>
-          </a:p>
-        </p:txBody>
-      </p:sp>
-      <p:pic>
-        <p:nvPicPr>
-          <p:cNvPr id="49" name="Picture 48" descr="fig_ui_teacher_desk.png"/>
-          <p:cNvPicPr>
-            <a:picLocks noChangeAspect="1"/>
-          </p:cNvPicPr>
+              <a:t>Comparative Benchmark Findings (Table 6.2 in Dissertation)</a:t>
+            </a:r>
+          </a:p>
+          <a:p>
+            <a:pPr>
+              <a:spcBef>
+                <a:spcPts val="300"/>
+              </a:spcBef>
+            </a:pPr>
+            <a:r>
+              <a:rPr b="1" sz="1100">
+                <a:solidFill>
+                  <a:srgbClr val="003366"/>
+                </a:solidFill>
+                <a:latin typeface="Arial"/>
+              </a:rPr>
+              <a:t>•  Clariq (Qwen2.5-7B Merged SFT + Turn Policy): </a:t>
+            </a:r>
+            <a:r>
+              <a:rPr sz="1050">
+                <a:solidFill>
+                  <a:srgbClr val="374151"/>
+                </a:solidFill>
+                <a:latin typeface="Arial"/>
+              </a:rPr>
+              <a:t>0% Direct Answer Leaks  •  100% Guiding Questions  •  0 Script Collapse Flags  •  3.31s Median Latency.
+Achieved absolute conversational compliance with zero direct answer disclosures across all 100 adversarial student probes.</a:t>
+            </a:r>
+          </a:p>
+          <a:p>
+            <a:pPr>
+              <a:spcBef>
+                <a:spcPts val="300"/>
+              </a:spcBef>
+            </a:pPr>
+            <a:r>
+              <a:rPr b="1" sz="1100">
+                <a:solidFill>
+                  <a:srgbClr val="003366"/>
+                </a:solidFill>
+                <a:latin typeface="Arial"/>
+              </a:rPr>
+              <a:t>•  Commercial GPT-4o (Frontier Model Baseline): </a:t>
+            </a:r>
+            <a:r>
+              <a:rPr sz="1050">
+                <a:solidFill>
+                  <a:srgbClr val="374151"/>
+                </a:solidFill>
+                <a:latin typeface="Arial"/>
+              </a:rPr>
+              <a:t>88% Direct Answer Dumps  •  Only 22% Guiding Questions  •  2.12s Latency.
+Completely fails Socratic restraint by immediately dispensing full solutions, robbing students of self-guided synthesis.</a:t>
+            </a:r>
+          </a:p>
+          <a:p>
+            <a:pPr>
+              <a:spcBef>
+                <a:spcPts val="300"/>
+              </a:spcBef>
+            </a:pPr>
+            <a:r>
+              <a:rPr b="1" sz="1100">
+                <a:solidFill>
+                  <a:srgbClr val="003366"/>
+                </a:solidFill>
+                <a:latin typeface="Arial"/>
+              </a:rPr>
+              <a:t>•  Qwen-4B LoRA (Raw Unmerged Baseline): </a:t>
+            </a:r>
+            <a:r>
+              <a:rPr sz="1050">
+                <a:solidFill>
+                  <a:srgbClr val="374151"/>
+                </a:solidFill>
+                <a:latin typeface="Arial"/>
+              </a:rPr>
+              <a:t>4% Answer Dumps  •  96% Questions  •  14 Script Collapse Flags  •  5.80s Latency.
+Suffered catastrophic prompt loop repetition on English prefixes; resolved completely by 7B weight merging.</a:t>
+            </a:r>
+          </a:p>
+          <a:p>
+            <a:pPr>
+              <a:spcBef>
+                <a:spcPts val="300"/>
+              </a:spcBef>
+            </a:pPr>
+            <a:r>
+              <a:rPr b="1" sz="1100">
+                <a:solidFill>
+                  <a:srgbClr val="003366"/>
+                </a:solidFill>
+                <a:latin typeface="Arial"/>
+              </a:rPr>
+              <a:t>•  Deterministic Socratic Gating (turn_policy.py): </a:t>
+            </a:r>
+            <a:r>
+              <a:rPr sz="1050">
+                <a:solidFill>
+                  <a:srgbClr val="374151"/>
+                </a:solidFill>
+                <a:latin typeface="Arial"/>
+              </a:rPr>
+              <a:t>Multi-stage deterministic validation intercepts raw LLM candidate outputs before transmission. If answer leakage or script repetition is detected, the policy dynamically injects a guiding scaffold probe.</a:t>
+            </a:r>
+          </a:p>
+        </p:txBody>
+      </p:sp>
+      <p:sp>
+        <p:nvSpPr>
+          <p:cNvPr id="42" name="TextBox 41"/>
+          <p:cNvSpPr txBox="1"/>
           <p:nvPr/>
-        </p:nvPicPr>
-        <p:blipFill>
-          <a:blip r:embed="rId8"/>
-          <a:stretch>
-            <a:fillRect/>
-          </a:stretch>
-        </p:blipFill>
-        <p:spPr>
-          <a:xfrm>
-            <a:off x="12289536" y="14218920"/>
-            <a:ext cx="2478024" cy="1280151"/>
+        </p:nvSpPr>
+        <p:spPr>
+          <a:xfrm>
+            <a:off x="731520" y="17785080"/>
+            <a:ext cx="19921118" cy="365760"/>
           </a:xfrm>
           <a:prstGeom prst="rect">
             <a:avLst/>
           </a:prstGeom>
-        </p:spPr>
-      </p:pic>
-      <p:sp>
-        <p:nvSpPr>
-          <p:cNvPr id="50" name="Rounded Rectangle 49"/>
+          <a:noFill/>
+        </p:spPr>
+        <p:txBody>
+          <a:bodyPr wrap="square" lIns="0" tIns="0" rIns="0" bIns="0">
+            <a:spAutoFit/>
+          </a:bodyPr>
+          <a:lstStyle/>
+          <a:p>
+            <a:pPr>
+              <a:defRPr sz="2000" b="1">
+                <a:solidFill>
+                  <a:srgbClr val="111827"/>
+                </a:solidFill>
+                <a:latin typeface="Arial"/>
+              </a:defRPr>
+            </a:pPr>
+            <a:r>
+              <a:t>Key Empirical Results &amp; Baseline Model Comparison</a:t>
+            </a:r>
+          </a:p>
+        </p:txBody>
+      </p:sp>
+      <p:sp>
+        <p:nvSpPr>
+          <p:cNvPr id="43" name="Rounded Rectangle 42"/>
           <p:cNvSpPr/>
           <p:nvPr/>
         </p:nvSpPr>
         <p:spPr>
           <a:xfrm>
-            <a:off x="15041880" y="13487400"/>
-            <a:ext cx="2697480" cy="4023360"/>
+            <a:off x="731520" y="18196560"/>
+            <a:ext cx="2697480" cy="1280160"/>
           </a:xfrm>
           <a:prstGeom prst="roundRect">
             <a:avLst/>
@@ -5436,14 +5227,14 @@
       </p:sp>
       <p:sp>
         <p:nvSpPr>
-          <p:cNvPr id="51" name="TextBox 50"/>
+          <p:cNvPr id="44" name="TextBox 43"/>
           <p:cNvSpPr txBox="1"/>
           <p:nvPr/>
         </p:nvSpPr>
         <p:spPr>
           <a:xfrm>
-            <a:off x="15115032" y="13560552"/>
-            <a:ext cx="2551176" cy="621792"/>
+            <a:off x="822960" y="18242280"/>
+            <a:ext cx="2514600" cy="1188720"/>
           </a:xfrm>
           <a:prstGeom prst="rect">
             <a:avLst/>
@@ -5457,7 +5248,23 @@
           <a:lstStyle/>
           <a:p>
             <a:pPr algn="ctr">
-              <a:defRPr sz="1150" b="1">
+              <a:defRPr sz="2500" b="1">
+                <a:solidFill>
+                  <a:srgbClr val="16A34A"/>
+                </a:solidFill>
+                <a:latin typeface="Arial"/>
+              </a:defRPr>
+            </a:pPr>
+            <a:r>
+              <a:t>0.873</a:t>
+            </a:r>
+          </a:p>
+          <a:p>
+            <a:pPr algn="ctr">
+              <a:spcBef>
+                <a:spcPts val="100"/>
+              </a:spcBef>
+              <a:defRPr sz="1000" b="1">
                 <a:solidFill>
                   <a:srgbClr val="111827"/>
                 </a:solidFill>
@@ -5465,49 +5272,45 @@
               </a:defRPr>
             </a:pPr>
             <a:r>
-              <a:t>Mastery Telemetry</a:t>
+              <a:t>Curriculum RAG</a:t>
             </a:r>
             <a:br/>
             <a:r>
-              <a:t>Progress Curves</a:t>
-            </a:r>
-          </a:p>
-        </p:txBody>
-      </p:sp>
-      <p:pic>
-        <p:nvPicPr>
-          <p:cNvPr id="52" name="Picture 51" descr="fig_student_progress.png"/>
-          <p:cNvPicPr>
-            <a:picLocks noChangeAspect="1"/>
-          </p:cNvPicPr>
-          <p:nvPr/>
-        </p:nvPicPr>
-        <p:blipFill>
-          <a:blip r:embed="rId9"/>
-          <a:stretch>
-            <a:fillRect/>
-          </a:stretch>
-        </p:blipFill>
-        <p:spPr>
-          <a:xfrm>
-            <a:off x="15151608" y="14218920"/>
-            <a:ext cx="2478024" cy="1892935"/>
-          </a:xfrm>
-          <a:prstGeom prst="rect">
-            <a:avLst/>
-          </a:prstGeom>
-        </p:spPr>
-      </p:pic>
-      <p:sp>
-        <p:nvSpPr>
-          <p:cNvPr id="53" name="Rounded Rectangle 52"/>
+              <a:t>Precision@3</a:t>
+            </a:r>
+          </a:p>
+          <a:p>
+            <a:pPr algn="ctr">
+              <a:spcBef>
+                <a:spcPts val="100"/>
+              </a:spcBef>
+              <a:defRPr sz="880">
+                <a:solidFill>
+                  <a:srgbClr val="6B7280"/>
+                </a:solidFill>
+                <a:latin typeface="Arial"/>
+              </a:defRPr>
+            </a:pPr>
+            <a:r>
+              <a:t>Target: &gt;= 0.85 (MET)</a:t>
+            </a:r>
+            <a:br/>
+            <a:r>
+              <a:t>+11.3% over cosine</a:t>
+            </a:r>
+          </a:p>
+        </p:txBody>
+      </p:sp>
+      <p:sp>
+        <p:nvSpPr>
+          <p:cNvPr id="45" name="Rounded Rectangle 44"/>
           <p:cNvSpPr/>
           <p:nvPr/>
         </p:nvSpPr>
         <p:spPr>
           <a:xfrm>
-            <a:off x="17903952" y="13487400"/>
-            <a:ext cx="2697480" cy="4023360"/>
+            <a:off x="3593592" y="18196560"/>
+            <a:ext cx="2697480" cy="1280160"/>
           </a:xfrm>
           <a:prstGeom prst="roundRect">
             <a:avLst/>
@@ -5545,14 +5348,14 @@
       </p:sp>
       <p:sp>
         <p:nvSpPr>
-          <p:cNvPr id="54" name="TextBox 53"/>
+          <p:cNvPr id="46" name="TextBox 45"/>
           <p:cNvSpPr txBox="1"/>
           <p:nvPr/>
         </p:nvSpPr>
         <p:spPr>
           <a:xfrm>
-            <a:off x="17977104" y="13560552"/>
-            <a:ext cx="2551176" cy="621792"/>
+            <a:off x="3685032" y="18242280"/>
+            <a:ext cx="2514600" cy="1188720"/>
           </a:xfrm>
           <a:prstGeom prst="rect">
             <a:avLst/>
@@ -5566,7 +5369,23 @@
           <a:lstStyle/>
           <a:p>
             <a:pPr algn="ctr">
-              <a:defRPr sz="1150" b="1">
+              <a:defRPr sz="2500" b="1">
+                <a:solidFill>
+                  <a:srgbClr val="16A34A"/>
+                </a:solidFill>
+                <a:latin typeface="Arial"/>
+              </a:defRPr>
+            </a:pPr>
+            <a:r>
+              <a:t>0%</a:t>
+            </a:r>
+          </a:p>
+          <a:p>
+            <a:pPr algn="ctr">
+              <a:spcBef>
+                <a:spcPts val="100"/>
+              </a:spcBef>
+              <a:defRPr sz="1000" b="1">
                 <a:solidFill>
                   <a:srgbClr val="111827"/>
                 </a:solidFill>
@@ -5574,85 +5393,45 @@
               </a:defRPr>
             </a:pPr>
             <a:r>
-              <a:t>Expo Mobile</a:t>
+              <a:t>Direct Answer</a:t>
             </a:r>
             <a:br/>
             <a:r>
-              <a:t>Client (React Native)</a:t>
-            </a:r>
-          </a:p>
-        </p:txBody>
-      </p:sp>
-      <p:pic>
-        <p:nvPicPr>
-          <p:cNvPr id="55" name="Picture 54" descr="fig_ui_mobile_app.png"/>
-          <p:cNvPicPr>
-            <a:picLocks noChangeAspect="1"/>
-          </p:cNvPicPr>
-          <p:nvPr/>
-        </p:nvPicPr>
-        <p:blipFill>
-          <a:blip r:embed="rId10"/>
-          <a:stretch>
-            <a:fillRect/>
-          </a:stretch>
-        </p:blipFill>
-        <p:spPr>
-          <a:xfrm>
-            <a:off x="18013680" y="14218920"/>
-            <a:ext cx="2478024" cy="5270290"/>
-          </a:xfrm>
-          <a:prstGeom prst="rect">
-            <a:avLst/>
-          </a:prstGeom>
-        </p:spPr>
-      </p:pic>
-      <p:sp>
-        <p:nvSpPr>
-          <p:cNvPr id="56" name="TextBox 55"/>
-          <p:cNvSpPr txBox="1"/>
-          <p:nvPr/>
-        </p:nvSpPr>
-        <p:spPr>
-          <a:xfrm>
-            <a:off x="731520" y="17785080"/>
-            <a:ext cx="19921118" cy="502920"/>
-          </a:xfrm>
-          <a:prstGeom prst="rect">
-            <a:avLst/>
-          </a:prstGeom>
-          <a:noFill/>
-        </p:spPr>
-        <p:txBody>
-          <a:bodyPr wrap="square" lIns="0" tIns="0" rIns="0" bIns="0">
-            <a:spAutoFit/>
-          </a:bodyPr>
-          <a:lstStyle/>
-          <a:p>
-            <a:pPr>
-              <a:defRPr sz="2300" b="1">
-                <a:solidFill>
-                  <a:srgbClr val="111827"/>
-                </a:solidFill>
-                <a:latin typeface="Arial"/>
-              </a:defRPr>
-            </a:pPr>
-            <a:r>
-              <a:t>Key Empirical Results, Findings &amp; Baseline Model Comparison</a:t>
-            </a:r>
-          </a:p>
-        </p:txBody>
-      </p:sp>
-      <p:sp>
-        <p:nvSpPr>
-          <p:cNvPr id="57" name="Rounded Rectangle 56"/>
+              <a:t>Dumps (Leakage)</a:t>
+            </a:r>
+          </a:p>
+          <a:p>
+            <a:pPr algn="ctr">
+              <a:spcBef>
+                <a:spcPts val="100"/>
+              </a:spcBef>
+              <a:defRPr sz="880">
+                <a:solidFill>
+                  <a:srgbClr val="6B7280"/>
+                </a:solidFill>
+                <a:latin typeface="Arial"/>
+              </a:defRPr>
+            </a:pPr>
+            <a:r>
+              <a:t>Baseline: 88% GPT-4o</a:t>
+            </a:r>
+            <a:br/>
+            <a:r>
+              <a:t>Total restraint</a:t>
+            </a:r>
+          </a:p>
+        </p:txBody>
+      </p:sp>
+      <p:sp>
+        <p:nvSpPr>
+          <p:cNvPr id="47" name="Rounded Rectangle 46"/>
           <p:cNvSpPr/>
           <p:nvPr/>
         </p:nvSpPr>
         <p:spPr>
           <a:xfrm>
-            <a:off x="731520" y="18269712"/>
-            <a:ext cx="2697480" cy="1874519"/>
+            <a:off x="6455664" y="18196560"/>
+            <a:ext cx="2697480" cy="1280160"/>
           </a:xfrm>
           <a:prstGeom prst="roundRect">
             <a:avLst/>
@@ -5690,14 +5469,14 @@
       </p:sp>
       <p:sp>
         <p:nvSpPr>
-          <p:cNvPr id="58" name="TextBox 57"/>
+          <p:cNvPr id="48" name="TextBox 47"/>
           <p:cNvSpPr txBox="1"/>
           <p:nvPr/>
         </p:nvSpPr>
         <p:spPr>
           <a:xfrm>
-            <a:off x="822960" y="18361152"/>
-            <a:ext cx="2514600" cy="1691640"/>
+            <a:off x="6547104" y="18242280"/>
+            <a:ext cx="2514600" cy="1188720"/>
           </a:xfrm>
           <a:prstGeom prst="rect">
             <a:avLst/>
@@ -5711,23 +5490,23 @@
           <a:lstStyle/>
           <a:p>
             <a:pPr algn="ctr">
-              <a:defRPr sz="2800" b="1">
-                <a:solidFill>
-                  <a:srgbClr val="16A34A"/>
-                </a:solidFill>
-                <a:latin typeface="Arial"/>
-              </a:defRPr>
-            </a:pPr>
-            <a:r>
-              <a:t>0.873</a:t>
+              <a:defRPr sz="2500" b="1">
+                <a:solidFill>
+                  <a:srgbClr val="003366"/>
+                </a:solidFill>
+                <a:latin typeface="Arial"/>
+              </a:defRPr>
+            </a:pPr>
+            <a:r>
+              <a:t>100%</a:t>
             </a:r>
           </a:p>
           <a:p>
             <a:pPr algn="ctr">
               <a:spcBef>
-                <a:spcPts val="300"/>
+                <a:spcPts val="100"/>
               </a:spcBef>
-              <a:defRPr sz="1200" b="1">
+              <a:defRPr sz="1000" b="1">
                 <a:solidFill>
                   <a:srgbClr val="111827"/>
                 </a:solidFill>
@@ -5735,19 +5514,19 @@
               </a:defRPr>
             </a:pPr>
             <a:r>
-              <a:t>Curriculum RAG</a:t>
+              <a:t>Guiding Questions</a:t>
             </a:r>
             <a:br/>
             <a:r>
-              <a:t>Precision@3</a:t>
+              <a:t>('?') Post-Policy</a:t>
             </a:r>
           </a:p>
           <a:p>
             <a:pPr algn="ctr">
               <a:spcBef>
-                <a:spcPts val="200"/>
+                <a:spcPts val="100"/>
               </a:spcBef>
-              <a:defRPr sz="950">
+              <a:defRPr sz="880">
                 <a:solidFill>
                   <a:srgbClr val="6B7280"/>
                 </a:solidFill>
@@ -5755,25 +5534,25 @@
               </a:defRPr>
             </a:pPr>
             <a:r>
-              <a:t>Target: &gt;= 0.85 (MET)</a:t>
+              <a:t>Baseline: 22% GPT-4o</a:t>
             </a:r>
             <a:br/>
             <a:r>
-              <a:t>+11.3% over raw cosine</a:t>
-            </a:r>
-          </a:p>
-        </p:txBody>
-      </p:sp>
-      <p:sp>
-        <p:nvSpPr>
-          <p:cNvPr id="59" name="Rounded Rectangle 58"/>
+              <a:t>Strict guidance</a:t>
+            </a:r>
+          </a:p>
+        </p:txBody>
+      </p:sp>
+      <p:sp>
+        <p:nvSpPr>
+          <p:cNvPr id="49" name="Rounded Rectangle 48"/>
           <p:cNvSpPr/>
           <p:nvPr/>
         </p:nvSpPr>
         <p:spPr>
           <a:xfrm>
-            <a:off x="3593592" y="18269712"/>
-            <a:ext cx="2697480" cy="1874519"/>
+            <a:off x="9317736" y="18196560"/>
+            <a:ext cx="2697480" cy="1280160"/>
           </a:xfrm>
           <a:prstGeom prst="roundRect">
             <a:avLst/>
@@ -5811,14 +5590,14 @@
       </p:sp>
       <p:sp>
         <p:nvSpPr>
-          <p:cNvPr id="60" name="TextBox 59"/>
+          <p:cNvPr id="50" name="TextBox 49"/>
           <p:cNvSpPr txBox="1"/>
           <p:nvPr/>
         </p:nvSpPr>
         <p:spPr>
           <a:xfrm>
-            <a:off x="3685032" y="18361152"/>
-            <a:ext cx="2514600" cy="1691640"/>
+            <a:off x="9409176" y="18242280"/>
+            <a:ext cx="2514600" cy="1188720"/>
           </a:xfrm>
           <a:prstGeom prst="rect">
             <a:avLst/>
@@ -5832,7 +5611,7 @@
           <a:lstStyle/>
           <a:p>
             <a:pPr algn="ctr">
-              <a:defRPr sz="2800" b="1">
+              <a:defRPr sz="2500" b="1">
                 <a:solidFill>
                   <a:srgbClr val="16A34A"/>
                 </a:solidFill>
@@ -5840,15 +5619,15 @@
               </a:defRPr>
             </a:pPr>
             <a:r>
-              <a:t>0%</a:t>
+              <a:t>0</a:t>
             </a:r>
           </a:p>
           <a:p>
             <a:pPr algn="ctr">
               <a:spcBef>
-                <a:spcPts val="300"/>
+                <a:spcPts val="100"/>
               </a:spcBef>
-              <a:defRPr sz="1200" b="1">
+              <a:defRPr sz="1000" b="1">
                 <a:solidFill>
                   <a:srgbClr val="111827"/>
                 </a:solidFill>
@@ -5856,19 +5635,19 @@
               </a:defRPr>
             </a:pPr>
             <a:r>
-              <a:t>Direct Answer</a:t>
+              <a:t>Script Collapse</a:t>
             </a:r>
             <a:br/>
             <a:r>
-              <a:t>Dumps (Leakage)</a:t>
+              <a:t>Flags (Memorization)</a:t>
             </a:r>
           </a:p>
           <a:p>
             <a:pPr algn="ctr">
               <a:spcBef>
-                <a:spcPts val="200"/>
+                <a:spcPts val="100"/>
               </a:spcBef>
-              <a:defRPr sz="950">
+              <a:defRPr sz="880">
                 <a:solidFill>
                   <a:srgbClr val="6B7280"/>
                 </a:solidFill>
@@ -5876,25 +5655,25 @@
               </a:defRPr>
             </a:pPr>
             <a:r>
-              <a:t>Baseline: 88% GPT-4o</a:t>
+              <a:t>Baseline: 14 in 4B Raw</a:t>
             </a:r>
             <a:br/>
             <a:r>
-              <a:t>Complete answer restraint</a:t>
-            </a:r>
-          </a:p>
-        </p:txBody>
-      </p:sp>
-      <p:sp>
-        <p:nvSpPr>
-          <p:cNvPr id="61" name="Rounded Rectangle 60"/>
+              <a:t>Resolved via 7B SFT</a:t>
+            </a:r>
+          </a:p>
+        </p:txBody>
+      </p:sp>
+      <p:sp>
+        <p:nvSpPr>
+          <p:cNvPr id="51" name="Rounded Rectangle 50"/>
           <p:cNvSpPr/>
           <p:nvPr/>
         </p:nvSpPr>
         <p:spPr>
           <a:xfrm>
-            <a:off x="6455664" y="18269712"/>
-            <a:ext cx="2697480" cy="1874519"/>
+            <a:off x="12179808" y="18196560"/>
+            <a:ext cx="2697480" cy="1280160"/>
           </a:xfrm>
           <a:prstGeom prst="roundRect">
             <a:avLst/>
@@ -5932,14 +5711,14 @@
       </p:sp>
       <p:sp>
         <p:nvSpPr>
-          <p:cNvPr id="62" name="TextBox 61"/>
+          <p:cNvPr id="52" name="TextBox 51"/>
           <p:cNvSpPr txBox="1"/>
           <p:nvPr/>
         </p:nvSpPr>
         <p:spPr>
           <a:xfrm>
-            <a:off x="6547104" y="18361152"/>
-            <a:ext cx="2514600" cy="1691640"/>
+            <a:off x="12271248" y="18242280"/>
+            <a:ext cx="2514600" cy="1188720"/>
           </a:xfrm>
           <a:prstGeom prst="rect">
             <a:avLst/>
@@ -5953,7 +5732,7 @@
           <a:lstStyle/>
           <a:p>
             <a:pPr algn="ctr">
-              <a:defRPr sz="2800" b="1">
+              <a:defRPr sz="2500" b="1">
                 <a:solidFill>
                   <a:srgbClr val="003366"/>
                 </a:solidFill>
@@ -5961,15 +5740,15 @@
               </a:defRPr>
             </a:pPr>
             <a:r>
-              <a:t>100%</a:t>
+              <a:t>3.31 s</a:t>
             </a:r>
           </a:p>
           <a:p>
             <a:pPr algn="ctr">
               <a:spcBef>
-                <a:spcPts val="300"/>
+                <a:spcPts val="100"/>
               </a:spcBef>
-              <a:defRPr sz="1200" b="1">
+              <a:defRPr sz="1000" b="1">
                 <a:solidFill>
                   <a:srgbClr val="111827"/>
                 </a:solidFill>
@@ -5977,19 +5756,19 @@
               </a:defRPr>
             </a:pPr>
             <a:r>
-              <a:t>Guiding Questions</a:t>
+              <a:t>Median Warm</a:t>
             </a:r>
             <a:br/>
             <a:r>
-              <a:t>('?') Post-Policy</a:t>
+              <a:t>Latency (ZeroGPU)</a:t>
             </a:r>
           </a:p>
           <a:p>
             <a:pPr algn="ctr">
               <a:spcBef>
-                <a:spcPts val="200"/>
+                <a:spcPts val="100"/>
               </a:spcBef>
-              <a:defRPr sz="950">
+              <a:defRPr sz="880">
                 <a:solidFill>
                   <a:srgbClr val="6B7280"/>
                 </a:solidFill>
@@ -5997,25 +5776,25 @@
               </a:defRPr>
             </a:pPr>
             <a:r>
-              <a:t>Baseline: 22% GPT-4o</a:t>
+              <a:t>Target: &lt;= 5.0s (MET)</a:t>
             </a:r>
             <a:br/>
             <a:r>
-              <a:t>Strict Socratic guidance</a:t>
-            </a:r>
-          </a:p>
-        </p:txBody>
-      </p:sp>
-      <p:sp>
-        <p:nvSpPr>
-          <p:cNvPr id="63" name="Rounded Rectangle 62"/>
+              <a:t>RunPod: 6.66s conc.</a:t>
+            </a:r>
+          </a:p>
+        </p:txBody>
+      </p:sp>
+      <p:sp>
+        <p:nvSpPr>
+          <p:cNvPr id="53" name="Rounded Rectangle 52"/>
           <p:cNvSpPr/>
           <p:nvPr/>
         </p:nvSpPr>
         <p:spPr>
           <a:xfrm>
-            <a:off x="9317736" y="18269712"/>
-            <a:ext cx="2697480" cy="1874519"/>
+            <a:off x="15041880" y="18196560"/>
+            <a:ext cx="2697480" cy="1280160"/>
           </a:xfrm>
           <a:prstGeom prst="roundRect">
             <a:avLst/>
@@ -6053,14 +5832,14 @@
       </p:sp>
       <p:sp>
         <p:nvSpPr>
-          <p:cNvPr id="64" name="TextBox 63"/>
+          <p:cNvPr id="54" name="TextBox 53"/>
           <p:cNvSpPr txBox="1"/>
           <p:nvPr/>
         </p:nvSpPr>
         <p:spPr>
           <a:xfrm>
-            <a:off x="9409176" y="18361152"/>
-            <a:ext cx="2514600" cy="1691640"/>
+            <a:off x="15133320" y="18242280"/>
+            <a:ext cx="2514600" cy="1188720"/>
           </a:xfrm>
           <a:prstGeom prst="rect">
             <a:avLst/>
@@ -6074,7 +5853,7 @@
           <a:lstStyle/>
           <a:p>
             <a:pPr algn="ctr">
-              <a:defRPr sz="2800" b="1">
+              <a:defRPr sz="2500" b="1">
                 <a:solidFill>
                   <a:srgbClr val="16A34A"/>
                 </a:solidFill>
@@ -6082,15 +5861,15 @@
               </a:defRPr>
             </a:pPr>
             <a:r>
-              <a:t>0</a:t>
+              <a:t>+2.80</a:t>
             </a:r>
           </a:p>
           <a:p>
             <a:pPr algn="ctr">
               <a:spcBef>
-                <a:spcPts val="300"/>
+                <a:spcPts val="100"/>
               </a:spcBef>
-              <a:defRPr sz="1200" b="1">
+              <a:defRPr sz="1000" b="1">
                 <a:solidFill>
                   <a:srgbClr val="111827"/>
                 </a:solidFill>
@@ -6098,19 +5877,19 @@
               </a:defRPr>
             </a:pPr>
             <a:r>
-              <a:t>Script Collapse</a:t>
+              <a:t>Mean Pilot</a:t>
             </a:r>
             <a:br/>
             <a:r>
-              <a:t>Flags (Memorization)</a:t>
+              <a:t>Learning Gain</a:t>
             </a:r>
           </a:p>
           <a:p>
             <a:pPr algn="ctr">
               <a:spcBef>
-                <a:spcPts val="200"/>
+                <a:spcPts val="100"/>
               </a:spcBef>
-              <a:defRPr sz="950">
+              <a:defRPr sz="880">
                 <a:solidFill>
                   <a:srgbClr val="6B7280"/>
                 </a:solidFill>
@@ -6118,25 +5897,25 @@
               </a:defRPr>
             </a:pPr>
             <a:r>
-              <a:t>Baseline: 14 in 4B Raw</a:t>
+              <a:t>Baseline: +1.20 Book</a:t>
             </a:r>
             <a:br/>
             <a:r>
-              <a:t>Resolved via 7B SFT merge</a:t>
-            </a:r>
-          </a:p>
-        </p:txBody>
-      </p:sp>
-      <p:sp>
-        <p:nvSpPr>
-          <p:cNvPr id="65" name="Rounded Rectangle 64"/>
+              <a:t>4.70 vs 3.20 post-score</a:t>
+            </a:r>
+          </a:p>
+        </p:txBody>
+      </p:sp>
+      <p:sp>
+        <p:nvSpPr>
+          <p:cNvPr id="55" name="Rounded Rectangle 54"/>
           <p:cNvSpPr/>
           <p:nvPr/>
         </p:nvSpPr>
         <p:spPr>
           <a:xfrm>
-            <a:off x="12179808" y="18269712"/>
-            <a:ext cx="2697480" cy="1874519"/>
+            <a:off x="17903952" y="18196560"/>
+            <a:ext cx="2697480" cy="1280160"/>
           </a:xfrm>
           <a:prstGeom prst="roundRect">
             <a:avLst/>
@@ -6174,14 +5953,14 @@
       </p:sp>
       <p:sp>
         <p:nvSpPr>
-          <p:cNvPr id="66" name="TextBox 65"/>
+          <p:cNvPr id="56" name="TextBox 55"/>
           <p:cNvSpPr txBox="1"/>
           <p:nvPr/>
         </p:nvSpPr>
         <p:spPr>
           <a:xfrm>
-            <a:off x="12271248" y="18361152"/>
-            <a:ext cx="2514600" cy="1691640"/>
+            <a:off x="17995392" y="18242280"/>
+            <a:ext cx="2514600" cy="1188720"/>
           </a:xfrm>
           <a:prstGeom prst="rect">
             <a:avLst/>
@@ -6195,7 +5974,7 @@
           <a:lstStyle/>
           <a:p>
             <a:pPr algn="ctr">
-              <a:defRPr sz="2800" b="1">
+              <a:defRPr sz="2500" b="1">
                 <a:solidFill>
                   <a:srgbClr val="003366"/>
                 </a:solidFill>
@@ -6203,15 +5982,15 @@
               </a:defRPr>
             </a:pPr>
             <a:r>
-              <a:t>3.31 s</a:t>
+              <a:t>88.8 / 100</a:t>
             </a:r>
           </a:p>
           <a:p>
             <a:pPr algn="ctr">
               <a:spcBef>
-                <a:spcPts val="300"/>
+                <a:spcPts val="100"/>
               </a:spcBef>
-              <a:defRPr sz="1200" b="1">
+              <a:defRPr sz="1000" b="1">
                 <a:solidFill>
                   <a:srgbClr val="111827"/>
                 </a:solidFill>
@@ -6219,19 +5998,19 @@
               </a:defRPr>
             </a:pPr>
             <a:r>
-              <a:t>Median Warm</a:t>
+              <a:t>System Usability</a:t>
             </a:r>
             <a:br/>
             <a:r>
-              <a:t>Latency (ZeroGPU)</a:t>
+              <a:t>Scale (SUS)</a:t>
             </a:r>
           </a:p>
           <a:p>
             <a:pPr algn="ctr">
               <a:spcBef>
-                <a:spcPts val="200"/>
+                <a:spcPts val="100"/>
               </a:spcBef>
-              <a:defRPr sz="950">
+              <a:defRPr sz="880">
                 <a:solidFill>
                   <a:srgbClr val="6B7280"/>
                 </a:solidFill>
@@ -6239,35 +6018,35 @@
               </a:defRPr>
             </a:pPr>
             <a:r>
-              <a:t>Target: &lt;= 5.0s (MET)</a:t>
+              <a:t>Target: &gt;= 70.0 (MET)</a:t>
             </a:r>
             <a:br/>
             <a:r>
-              <a:t>RunPod: 6.66s concurrent</a:t>
-            </a:r>
-          </a:p>
-        </p:txBody>
-      </p:sp>
-      <p:sp>
-        <p:nvSpPr>
-          <p:cNvPr id="67" name="Rounded Rectangle 66"/>
+              <a:t>Rating: 'Excellent'</a:t>
+            </a:r>
+          </a:p>
+        </p:txBody>
+      </p:sp>
+      <p:sp>
+        <p:nvSpPr>
+          <p:cNvPr id="57" name="Rounded Rectangle 56"/>
           <p:cNvSpPr/>
           <p:nvPr/>
         </p:nvSpPr>
         <p:spPr>
           <a:xfrm>
-            <a:off x="15041880" y="18269712"/>
-            <a:ext cx="2697480" cy="1874519"/>
+            <a:off x="731520" y="19613880"/>
+            <a:ext cx="19921118" cy="868680"/>
           </a:xfrm>
           <a:prstGeom prst="roundRect">
             <a:avLst/>
           </a:prstGeom>
           <a:solidFill>
-            <a:srgbClr val="FFFFFF"/>
+            <a:srgbClr val="F0FDF4"/>
           </a:solidFill>
           <a:ln w="19050">
             <a:solidFill>
-              <a:srgbClr val="D1D5DB"/>
+              <a:srgbClr val="BBF7D0"/>
             </a:solidFill>
           </a:ln>
         </p:spPr>
@@ -6295,101 +6074,23 @@
       </p:sp>
       <p:sp>
         <p:nvSpPr>
-          <p:cNvPr id="68" name="TextBox 67"/>
-          <p:cNvSpPr txBox="1"/>
-          <p:nvPr/>
-        </p:nvSpPr>
-        <p:spPr>
-          <a:xfrm>
-            <a:off x="15133320" y="18361152"/>
-            <a:ext cx="2514600" cy="1691640"/>
-          </a:xfrm>
-          <a:prstGeom prst="rect">
-            <a:avLst/>
-          </a:prstGeom>
-          <a:noFill/>
-        </p:spPr>
-        <p:txBody>
-          <a:bodyPr wrap="square" lIns="0" tIns="0" rIns="0" bIns="0">
-            <a:spAutoFit/>
-          </a:bodyPr>
-          <a:lstStyle/>
-          <a:p>
-            <a:pPr algn="ctr">
-              <a:defRPr sz="2800" b="1">
-                <a:solidFill>
-                  <a:srgbClr val="16A34A"/>
-                </a:solidFill>
-                <a:latin typeface="Arial"/>
-              </a:defRPr>
-            </a:pPr>
-            <a:r>
-              <a:t>+2.80</a:t>
-            </a:r>
-          </a:p>
-          <a:p>
-            <a:pPr algn="ctr">
-              <a:spcBef>
-                <a:spcPts val="300"/>
-              </a:spcBef>
-              <a:defRPr sz="1200" b="1">
-                <a:solidFill>
-                  <a:srgbClr val="111827"/>
-                </a:solidFill>
-                <a:latin typeface="Arial"/>
-              </a:defRPr>
-            </a:pPr>
-            <a:r>
-              <a:t>Mean Pilot</a:t>
-            </a:r>
-            <a:br/>
-            <a:r>
-              <a:t>Learning Gain</a:t>
-            </a:r>
-          </a:p>
-          <a:p>
-            <a:pPr algn="ctr">
-              <a:spcBef>
-                <a:spcPts val="200"/>
-              </a:spcBef>
-              <a:defRPr sz="950">
-                <a:solidFill>
-                  <a:srgbClr val="6B7280"/>
-                </a:solidFill>
-                <a:latin typeface="Arial"/>
-              </a:defRPr>
-            </a:pPr>
-            <a:r>
-              <a:t>Baseline: +1.20 Textbook</a:t>
-            </a:r>
-            <a:br/>
-            <a:r>
-              <a:t>p = 5.67e-6 (Stat. Sig.)</a:t>
-            </a:r>
-          </a:p>
-        </p:txBody>
-      </p:sp>
-      <p:sp>
-        <p:nvSpPr>
-          <p:cNvPr id="69" name="Rounded Rectangle 68"/>
+          <p:cNvPr id="58" name="Rounded Rectangle 57"/>
           <p:cNvSpPr/>
           <p:nvPr/>
         </p:nvSpPr>
         <p:spPr>
           <a:xfrm>
-            <a:off x="17903952" y="18269712"/>
-            <a:ext cx="2697480" cy="1874519"/>
+            <a:off x="868680" y="19677888"/>
+            <a:ext cx="1645920" cy="731520"/>
           </a:xfrm>
           <a:prstGeom prst="roundRect">
             <a:avLst/>
           </a:prstGeom>
           <a:solidFill>
-            <a:srgbClr val="FFFFFF"/>
+            <a:srgbClr val="16A34A"/>
           </a:solidFill>
-          <a:ln w="19050">
-            <a:solidFill>
-              <a:srgbClr val="D1D5DB"/>
-            </a:solidFill>
+          <a:ln>
+            <a:noFill/>
           </a:ln>
         </p:spPr>
         <p:style>
@@ -6410,20 +6111,34 @@
           <a:bodyPr rtlCol="0" anchor="ctr"/>
           <a:lstStyle/>
           <a:p>
-            <a:pPr algn="ctr"/>
-          </a:p>
-        </p:txBody>
-      </p:sp>
-      <p:sp>
-        <p:nvSpPr>
-          <p:cNvPr id="70" name="TextBox 69"/>
+            <a:pPr algn="ctr">
+              <a:defRPr sz="1250" b="1">
+                <a:solidFill>
+                  <a:srgbClr val="FFFFFF"/>
+                </a:solidFill>
+                <a:latin typeface="Arial"/>
+              </a:defRPr>
+            </a:pPr>
+            <a:r>
+              <a:t>UAT PILOT</a:t>
+            </a:r>
+            <a:br/>
+            <a:r>
+              <a:t>TRIAL</a:t>
+            </a:r>
+          </a:p>
+        </p:txBody>
+      </p:sp>
+      <p:sp>
+        <p:nvSpPr>
+          <p:cNvPr id="59" name="TextBox 58"/>
           <p:cNvSpPr txBox="1"/>
           <p:nvPr/>
         </p:nvSpPr>
         <p:spPr>
           <a:xfrm>
-            <a:off x="17995392" y="18361152"/>
-            <a:ext cx="2514600" cy="1691640"/>
+            <a:off x="2697480" y="19650456"/>
+            <a:ext cx="17739360" cy="777240"/>
           </a:xfrm>
           <a:prstGeom prst="rect">
             <a:avLst/>
@@ -6436,196 +6151,54 @@
           </a:bodyPr>
           <a:lstStyle/>
           <a:p>
-            <a:pPr algn="ctr">
-              <a:defRPr sz="2800" b="1">
-                <a:solidFill>
-                  <a:srgbClr val="003366"/>
-                </a:solidFill>
-                <a:latin typeface="Arial"/>
-              </a:defRPr>
-            </a:pPr>
-            <a:r>
-              <a:t>88.8 / 100</a:t>
-            </a:r>
-          </a:p>
-          <a:p>
-            <a:pPr algn="ctr">
+            <a:pPr>
+              <a:defRPr sz="1250" b="1">
+                <a:solidFill>
+                  <a:srgbClr val="111827"/>
+                </a:solidFill>
+                <a:latin typeface="Arial"/>
+              </a:defRPr>
+            </a:pPr>
+            <a:r>
+              <a:t>User Acceptance Testing (UAT) &amp; Empirical Pilot Feasibility Trial  (N = 20 Class 10 Students, Ages 15–16)</a:t>
+            </a:r>
+          </a:p>
+          <a:p>
+            <a:pPr>
               <a:spcBef>
-                <a:spcPts val="300"/>
+                <a:spcPts val="150"/>
               </a:spcBef>
-              <a:defRPr sz="1200" b="1">
-                <a:solidFill>
-                  <a:srgbClr val="111827"/>
-                </a:solidFill>
-                <a:latin typeface="Arial"/>
-              </a:defRPr>
-            </a:pPr>
-            <a:r>
-              <a:t>System Usability</a:t>
+              <a:defRPr sz="1000">
+                <a:solidFill>
+                  <a:srgbClr val="374151"/>
+                </a:solidFill>
+                <a:latin typeface="Arial"/>
+              </a:defRPr>
+            </a:pPr>
+            <a:r>
+              <a:t>• Higher Comprehension: Clariq students scored 4.70 / 5.0 on post-study assessment vs. 3.20 / 5.0 for CDC textbook self-study (+1.50 higher comprehension; +2.80 learning gain).</a:t>
             </a:r>
             <a:br/>
             <a:r>
-              <a:t>Scale (SUS)</a:t>
-            </a:r>
-          </a:p>
-          <a:p>
-            <a:pPr algn="ctr">
-              <a:spcBef>
-                <a:spcPts val="200"/>
-              </a:spcBef>
-              <a:defRPr sz="950">
-                <a:solidFill>
-                  <a:srgbClr val="6B7280"/>
-                </a:solidFill>
-                <a:latin typeface="Arial"/>
-              </a:defRPr>
-            </a:pPr>
-            <a:r>
-              <a:t>Target: &gt;= 70.0 (MET)</a:t>
+              <a:t>• Time Efficiency: 34.8% reduction in study duration (8.35 min with Clariq vs. 12.80 min with textbook self-study) while maintaining deeper understanding.</a:t>
             </a:r>
             <a:br/>
             <a:r>
-              <a:t>Adjective: 'Excellent'</a:t>
-            </a:r>
-          </a:p>
-        </p:txBody>
-      </p:sp>
-      <p:sp>
-        <p:nvSpPr>
-          <p:cNvPr id="71" name="Rounded Rectangle 70"/>
-          <p:cNvSpPr/>
-          <p:nvPr/>
-        </p:nvSpPr>
-        <p:spPr>
-          <a:xfrm>
-            <a:off x="731520" y="20345400"/>
-            <a:ext cx="19921118" cy="1143000"/>
-          </a:xfrm>
-          <a:prstGeom prst="roundRect">
-            <a:avLst/>
-          </a:prstGeom>
-          <a:solidFill>
-            <a:srgbClr val="F9FAFB"/>
-          </a:solidFill>
-          <a:ln w="19050">
-            <a:solidFill>
-              <a:srgbClr val="D1D5DB"/>
-            </a:solidFill>
-          </a:ln>
-        </p:spPr>
-        <p:style>
-          <a:lnRef idx="1">
-            <a:schemeClr val="accent1"/>
-          </a:lnRef>
-          <a:fillRef idx="3">
-            <a:schemeClr val="accent1"/>
-          </a:fillRef>
-          <a:effectRef idx="2">
-            <a:schemeClr val="accent1"/>
-          </a:effectRef>
-          <a:fontRef idx="minor">
-            <a:schemeClr val="lt1"/>
-          </a:fontRef>
-        </p:style>
-        <p:txBody>
-          <a:bodyPr rtlCol="0" anchor="ctr"/>
-          <a:lstStyle/>
-          <a:p>
-            <a:pPr algn="ctr"/>
-          </a:p>
-        </p:txBody>
-      </p:sp>
-      <p:sp>
-        <p:nvSpPr>
-          <p:cNvPr id="72" name="Rounded Rectangle 71"/>
-          <p:cNvSpPr/>
-          <p:nvPr/>
-        </p:nvSpPr>
-        <p:spPr>
-          <a:xfrm>
-            <a:off x="960120" y="20500848"/>
-            <a:ext cx="1280160" cy="804672"/>
-          </a:xfrm>
-          <a:prstGeom prst="roundRect">
-            <a:avLst/>
-          </a:prstGeom>
-          <a:solidFill>
-            <a:srgbClr val="102D24"/>
-          </a:solidFill>
-          <a:ln w="19050">
-            <a:solidFill>
-              <a:srgbClr val="102D24"/>
-            </a:solidFill>
-          </a:ln>
-        </p:spPr>
-        <p:style>
-          <a:lnRef idx="1">
-            <a:schemeClr val="accent1"/>
-          </a:lnRef>
-          <a:fillRef idx="3">
-            <a:schemeClr val="accent1"/>
-          </a:fillRef>
-          <a:effectRef idx="2">
-            <a:schemeClr val="accent1"/>
-          </a:effectRef>
-          <a:fontRef idx="minor">
-            <a:schemeClr val="lt1"/>
-          </a:fontRef>
-        </p:style>
-        <p:txBody>
-          <a:bodyPr rtlCol="0" anchor="ctr"/>
-          <a:lstStyle/>
-          <a:p>
-            <a:pPr algn="ctr"/>
-          </a:p>
-        </p:txBody>
-      </p:sp>
-      <p:sp>
-        <p:nvSpPr>
-          <p:cNvPr id="73" name="TextBox 72"/>
+              <a:t>• High Usability: 88.8 / 100 System Usability Scale (SUS) rating ('Excellent' usability across all 10 standard items). Preliminary trial focused on Chemical Acids, Bases &amp; Salts.</a:t>
+            </a:r>
+          </a:p>
+        </p:txBody>
+      </p:sp>
+      <p:sp>
+        <p:nvSpPr>
+          <p:cNvPr id="60" name="TextBox 59"/>
           <p:cNvSpPr txBox="1"/>
           <p:nvPr/>
         </p:nvSpPr>
         <p:spPr>
           <a:xfrm>
-            <a:off x="960120" y="20647152"/>
-            <a:ext cx="1280160" cy="502920"/>
-          </a:xfrm>
-          <a:prstGeom prst="rect">
-            <a:avLst/>
-          </a:prstGeom>
-          <a:noFill/>
-        </p:spPr>
-        <p:txBody>
-          <a:bodyPr wrap="none">
-            <a:spAutoFit/>
-          </a:bodyPr>
-          <a:lstStyle/>
-          <a:p>
-            <a:pPr algn="ctr">
-              <a:defRPr sz="2000" b="1">
-                <a:solidFill>
-                  <a:srgbClr val="FFFFFF"/>
-                </a:solidFill>
-                <a:latin typeface="Arial"/>
-              </a:defRPr>
-            </a:pPr>
-            <a:r>
-              <a:t>UAT</a:t>
-            </a:r>
-          </a:p>
-        </p:txBody>
-      </p:sp>
-      <p:sp>
-        <p:nvSpPr>
-          <p:cNvPr id="74" name="TextBox 73"/>
-          <p:cNvSpPr txBox="1"/>
-          <p:nvPr/>
-        </p:nvSpPr>
-        <p:spPr>
-          <a:xfrm>
-            <a:off x="2423160" y="20436840"/>
-            <a:ext cx="18013680" cy="960120"/>
+            <a:off x="731520" y="20619720"/>
+            <a:ext cx="11155680" cy="365760"/>
           </a:xfrm>
           <a:prstGeom prst="rect">
             <a:avLst/>
@@ -6639,7 +6212,7 @@
           <a:lstStyle/>
           <a:p>
             <a:pPr>
-              <a:defRPr sz="1400" b="1">
+              <a:defRPr sz="2000" b="1">
                 <a:solidFill>
                   <a:srgbClr val="111827"/>
                 </a:solidFill>
@@ -6647,73 +6220,21 @@
               </a:defRPr>
             </a:pPr>
             <a:r>
-              <a:t>Controlled Empirical Pilot User Study (N = 20 Class 10 Secondary Students in Nepal, Ages 15–16)</a:t>
-            </a:r>
-          </a:p>
-          <a:p>
-            <a:pPr>
-              <a:spcBef>
-                <a:spcPts val="200"/>
-              </a:spcBef>
-              <a:defRPr sz="1150">
-                <a:solidFill>
-                  <a:srgbClr val="374151"/>
-                </a:solidFill>
-                <a:latin typeface="Arial"/>
-              </a:defRPr>
-            </a:pPr>
-            <a:r>
-              <a:t>Randomized between-subjects trial comparing Clariq Socratic AI Tutor (n=10) vs. CDC Textbook Self-Study (n=10) on Chemical Acids, Bases, and Salts. Baseline equivalence confirmed (1.90 vs. 2.00, p = 0.75). Clariq users scored 4.70/5.0 vs. Textbook 3.20/5.0 (t = 5.960, p = 1.25e-5, Cohen's d = 2.666), achieved +2.80 learning gain, studied 34.8% less time (8.35 min vs. 12.80 min, t = -13.93, p &lt; 0.0001), and rated usability at SUS 88.8 / 100.</a:t>
-            </a:r>
-          </a:p>
-        </p:txBody>
-      </p:sp>
-      <p:sp>
-        <p:nvSpPr>
-          <p:cNvPr id="75" name="TextBox 74"/>
+              <a:t>Practical Implications &amp; Educational Significance</a:t>
+            </a:r>
+          </a:p>
+        </p:txBody>
+      </p:sp>
+      <p:sp>
+        <p:nvSpPr>
+          <p:cNvPr id="61" name="TextBox 60"/>
           <p:cNvSpPr txBox="1"/>
           <p:nvPr/>
         </p:nvSpPr>
         <p:spPr>
           <a:xfrm>
-            <a:off x="731520" y="21762720"/>
-            <a:ext cx="11155680" cy="502920"/>
-          </a:xfrm>
-          <a:prstGeom prst="rect">
-            <a:avLst/>
-          </a:prstGeom>
-          <a:noFill/>
-        </p:spPr>
-        <p:txBody>
-          <a:bodyPr wrap="square" lIns="0" tIns="0" rIns="0" bIns="0">
-            <a:spAutoFit/>
-          </a:bodyPr>
-          <a:lstStyle/>
-          <a:p>
-            <a:pPr>
-              <a:defRPr sz="2300" b="1">
-                <a:solidFill>
-                  <a:srgbClr val="111827"/>
-                </a:solidFill>
-                <a:latin typeface="Arial"/>
-              </a:defRPr>
-            </a:pPr>
-            <a:r>
-              <a:t>Practical Implications &amp; Educational Significance</a:t>
-            </a:r>
-          </a:p>
-        </p:txBody>
-      </p:sp>
-      <p:sp>
-        <p:nvSpPr>
-          <p:cNvPr id="76" name="TextBox 75"/>
-          <p:cNvSpPr txBox="1"/>
-          <p:nvPr/>
-        </p:nvSpPr>
-        <p:spPr>
-          <a:xfrm>
-            <a:off x="731520" y="22219920"/>
-            <a:ext cx="11155680" cy="1463040"/>
+            <a:off x="731520" y="20985480"/>
+            <a:ext cx="11155680" cy="1325880"/>
           </a:xfrm>
           <a:prstGeom prst="rect">
             <a:avLst/>
@@ -6732,22 +6253,22 @@
               </a:spcAft>
             </a:pPr>
             <a:r>
-              <a:rPr b="1" sz="1200">
+              <a:rPr b="1" sz="1100">
                 <a:solidFill>
                   <a:srgbClr val="003366"/>
                 </a:solidFill>
                 <a:latin typeface="Arial"/>
               </a:rPr>
-              <a:t>•  Bridging the Educational Resource Gap: </a:t>
-            </a:r>
-            <a:r>
-              <a:rPr sz="1150">
+              <a:t>•  Bridging the Rural Educational Divide: </a:t>
+            </a:r>
+            <a:r>
+              <a:rPr sz="1019">
                 <a:solidFill>
                   <a:srgbClr val="374151"/>
                 </a:solidFill>
                 <a:latin typeface="Arial"/>
               </a:rPr>
-              <a:t>Democratizes personalized 1-on-1 Socratic tutoring for rural community school students who cannot afford commercial private tuition centers ($15–$40/month).</a:t>
+              <a:t>Provides free 1-on-1 Socratic tutoring to rural public school students who cannot afford private tuition ($15–$40/mo). Designed specifically to operate over low-cost smartphones even under constrained educational resources.</a:t>
             </a:r>
           </a:p>
           <a:p>
@@ -6757,7 +6278,7 @@
               </a:spcAft>
             </a:pPr>
             <a:r>
-              <a:rPr b="1" sz="1200">
+              <a:rPr b="1" sz="1100">
                 <a:solidFill>
                   <a:srgbClr val="003366"/>
                 </a:solidFill>
@@ -6766,13 +6287,13 @@
               <a:t>•  Protecting Cognitive Autonomy: </a:t>
             </a:r>
             <a:r>
-              <a:rPr sz="1150">
+              <a:rPr sz="1019">
                 <a:solidFill>
                   <a:srgbClr val="374151"/>
                 </a:solidFill>
                 <a:latin typeface="Arial"/>
               </a:rPr>
-              <a:t>Eliminating answer dumping (0% leakage) prevents cognitive surrender and ensures that secondary students actively synthesize scientific principles rather than passively copying solutions.</a:t>
+              <a:t>Eliminating direct answer dumping (0% leakage) prevents cognitive surrender and ensures secondary students actively synthesize scientific principles rather than passively copying solutions.</a:t>
             </a:r>
           </a:p>
           <a:p>
@@ -6782,36 +6303,36 @@
               </a:spcAft>
             </a:pPr>
             <a:r>
-              <a:rPr b="1" sz="1200">
+              <a:rPr b="1" sz="1100">
                 <a:solidFill>
                   <a:srgbClr val="003366"/>
                 </a:solidFill>
                 <a:latin typeface="Arial"/>
               </a:rPr>
-              <a:t>•  Teacher Empowerment: </a:t>
-            </a:r>
-            <a:r>
-              <a:rPr sz="1150">
+              <a:t>•  Teacher Empowerment &amp; Classroom Interventions: </a:t>
+            </a:r>
+            <a:r>
+              <a:rPr sz="1019">
                 <a:solidFill>
                   <a:srgbClr val="374151"/>
                 </a:solidFill>
                 <a:latin typeface="Arial"/>
               </a:rPr>
-              <a:t>Translates continuous conversational turns into concept-level mastery heatmaps and automated confusion alerts, enabling educators to prioritize targeted classroom interventions.</a:t>
-            </a:r>
-          </a:p>
-        </p:txBody>
-      </p:sp>
-      <p:sp>
-        <p:nvSpPr>
-          <p:cNvPr id="77" name="TextBox 76"/>
+              <a:t>Converts conversational turns into concept-level mastery heatmaps and automated 3-turn confusion alerts, enabling overburdened educators to prioritize targeted small-group classroom support.</a:t>
+            </a:r>
+          </a:p>
+        </p:txBody>
+      </p:sp>
+      <p:sp>
+        <p:nvSpPr>
+          <p:cNvPr id="62" name="TextBox 61"/>
           <p:cNvSpPr txBox="1"/>
           <p:nvPr/>
         </p:nvSpPr>
         <p:spPr>
           <a:xfrm>
-            <a:off x="731520" y="23820120"/>
-            <a:ext cx="11155680" cy="502920"/>
+            <a:off x="731520" y="22219920"/>
+            <a:ext cx="11155680" cy="365760"/>
           </a:xfrm>
           <a:prstGeom prst="rect">
             <a:avLst/>
@@ -6825,7 +6346,7 @@
           <a:lstStyle/>
           <a:p>
             <a:pPr>
-              <a:defRPr sz="2300" b="1">
+              <a:defRPr sz="2000" b="1">
                 <a:solidFill>
                   <a:srgbClr val="111827"/>
                 </a:solidFill>
@@ -6840,118 +6361,14 @@
       </p:sp>
       <p:sp>
         <p:nvSpPr>
-          <p:cNvPr id="78" name="TextBox 77"/>
+          <p:cNvPr id="63" name="TextBox 62"/>
           <p:cNvSpPr txBox="1"/>
           <p:nvPr/>
         </p:nvSpPr>
         <p:spPr>
           <a:xfrm>
-            <a:off x="731520" y="24277320"/>
-            <a:ext cx="11155680" cy="2011680"/>
-          </a:xfrm>
-          <a:prstGeom prst="rect">
-            <a:avLst/>
-          </a:prstGeom>
-          <a:noFill/>
-        </p:spPr>
-        <p:txBody>
-          <a:bodyPr wrap="square" lIns="0" tIns="0" rIns="0" bIns="0">
-            <a:spAutoFit/>
-          </a:bodyPr>
-          <a:lstStyle/>
-          <a:p>
-            <a:pPr>
-              <a:spcAft>
-                <a:spcPts val="300"/>
-              </a:spcAft>
-              <a:defRPr sz="1200">
-                <a:solidFill>
-                  <a:srgbClr val="374151"/>
-                </a:solidFill>
-                <a:latin typeface="Arial"/>
-              </a:defRPr>
-            </a:pPr>
-            <a:r>
-              <a:t>Dissertation Conclusion: Clariq validates that fine-tuning open-weight models (Qwen2.5-7B Merged SFT) combined with deterministic turn policy gating successfully enforces Socratic dialogue restraint (0% answer dumps) while delivering significant comprehension gains (+2.80) and 34.8% study time reductions on Nepal's national Class 10 SEE Science curriculum.</a:t>
-            </a:r>
-          </a:p>
-          <a:p>
-            <a:pPr>
-              <a:defRPr sz="1100">
-                <a:solidFill>
-                  <a:srgbClr val="003366"/>
-                </a:solidFill>
-                <a:latin typeface="Arial"/>
-              </a:defRPr>
-            </a:pPr>
-            <a:r>
-              <a:t>Strategic Future Work:</a:t>
-            </a:r>
-            <a:br/>
-            <a:r>
-              <a:t>•  1. Recursive Conversational Memory: Implement multi-turn conversational state tracking across extended learning sessions.</a:t>
-            </a:r>
-            <a:br/>
-            <a:r>
-              <a:t>•  2. Formal Educator Panel Validation: Convene expert science teachers to compute inter-rater agreement (Cohen's κ) on graph edges.</a:t>
-            </a:r>
-            <a:br/>
-            <a:r>
-              <a:t>•  3. Longitudinal Field Trials: Conduct multi-school trials across rural and urban schools measuring 6-week delayed knowledge retention.</a:t>
-            </a:r>
-            <a:br/>
-            <a:r>
-              <a:t>•  4. Offline Edge Quantization: Deploy GGUF-quantized models (3B/7B) on low-cost offline tablets for off-grid Himalayan classrooms.</a:t>
-            </a:r>
-          </a:p>
-        </p:txBody>
-      </p:sp>
-      <p:sp>
-        <p:nvSpPr>
-          <p:cNvPr id="79" name="TextBox 78"/>
-          <p:cNvSpPr txBox="1"/>
-          <p:nvPr/>
-        </p:nvSpPr>
-        <p:spPr>
-          <a:xfrm>
-            <a:off x="731520" y="26426160"/>
-            <a:ext cx="11155680" cy="502920"/>
-          </a:xfrm>
-          <a:prstGeom prst="rect">
-            <a:avLst/>
-          </a:prstGeom>
-          <a:noFill/>
-        </p:spPr>
-        <p:txBody>
-          <a:bodyPr wrap="square" lIns="0" tIns="0" rIns="0" bIns="0">
-            <a:spAutoFit/>
-          </a:bodyPr>
-          <a:lstStyle/>
-          <a:p>
-            <a:pPr>
-              <a:defRPr sz="2000" b="1">
-                <a:solidFill>
-                  <a:srgbClr val="111827"/>
-                </a:solidFill>
-                <a:latin typeface="Arial"/>
-              </a:defRPr>
-            </a:pPr>
-            <a:r>
-              <a:t>References</a:t>
-            </a:r>
-          </a:p>
-        </p:txBody>
-      </p:sp>
-      <p:sp>
-        <p:nvSpPr>
-          <p:cNvPr id="80" name="TextBox 79"/>
-          <p:cNvSpPr txBox="1"/>
-          <p:nvPr/>
-        </p:nvSpPr>
-        <p:spPr>
-          <a:xfrm>
-            <a:off x="731520" y="26837640"/>
-            <a:ext cx="11155680" cy="2926080"/>
+            <a:off x="731520" y="22585680"/>
+            <a:ext cx="11155680" cy="1828800"/>
           </a:xfrm>
           <a:prstGeom prst="rect">
             <a:avLst/>
@@ -6968,23 +6385,111 @@
               <a:spcAft>
                 <a:spcPts val="200"/>
               </a:spcAft>
-              <a:defRPr sz="1000">
-                <a:solidFill>
-                  <a:srgbClr val="6B7280"/>
-                </a:solidFill>
-                <a:latin typeface="Arial"/>
-              </a:defRPr>
-            </a:pPr>
-            <a:r>
-              <a:t>•  Bastani, H. et al. (2025) 'Generative AI can harm learning: Evidence from high school classrooms'.</a:t>
-            </a:r>
-          </a:p>
+              <a:defRPr sz="1100">
+                <a:solidFill>
+                  <a:srgbClr val="374151"/>
+                </a:solidFill>
+                <a:latin typeface="Arial"/>
+              </a:defRPr>
+            </a:pPr>
+            <a:r>
+              <a:t>Dissertation Conclusion: Clariq validates that fine-tuning open-weight models (Qwen2.5-7B Merged SFT) combined with deterministic turn policy gating successfully enforces Socratic dialogue restraint (0% answer dumps) while delivering significant comprehension gains (+2.80) and 34.8% study time reductions on Nepal's national Class 10 SEE Science curriculum.</a:t>
+            </a:r>
+          </a:p>
+          <a:p>
+            <a:pPr>
+              <a:defRPr sz="1019">
+                <a:solidFill>
+                  <a:srgbClr val="003366"/>
+                </a:solidFill>
+                <a:latin typeface="Arial"/>
+              </a:defRPr>
+            </a:pPr>
+            <a:r>
+              <a:t>Strategic Future Work (4 Pillars):</a:t>
+            </a:r>
+            <a:br/>
+            <a:r>
+              <a:t>•  1. Recursive Conversational Memory: Implement multi-turn conversational state tracking across extended learning sessions.</a:t>
+            </a:r>
+            <a:br/>
+            <a:r>
+              <a:t>•  2. Formal Educator Panel Validation: Convene expert science teachers to compute inter-rater agreement (Cohen's κ) on graph edges.</a:t>
+            </a:r>
+            <a:br/>
+            <a:r>
+              <a:t>•  3. Longitudinal Field Trials: Conduct multi-school trials across rural and urban schools measuring 6-week delayed knowledge retention.</a:t>
+            </a:r>
+            <a:br/>
+            <a:r>
+              <a:t>•  4. Offline Edge Quantization: Deploy GGUF-quantized models (3B/7B) on low-cost offline tablets for off-grid Himalayan classrooms.</a:t>
+            </a:r>
+          </a:p>
+        </p:txBody>
+      </p:sp>
+      <p:sp>
+        <p:nvSpPr>
+          <p:cNvPr id="64" name="TextBox 63"/>
+          <p:cNvSpPr txBox="1"/>
+          <p:nvPr/>
+        </p:nvSpPr>
+        <p:spPr>
+          <a:xfrm>
+            <a:off x="731520" y="24323040"/>
+            <a:ext cx="11155680" cy="365760"/>
+          </a:xfrm>
+          <a:prstGeom prst="rect">
+            <a:avLst/>
+          </a:prstGeom>
+          <a:noFill/>
+        </p:spPr>
+        <p:txBody>
+          <a:bodyPr wrap="square" lIns="0" tIns="0" rIns="0" bIns="0">
+            <a:spAutoFit/>
+          </a:bodyPr>
+          <a:lstStyle/>
+          <a:p>
+            <a:pPr>
+              <a:defRPr sz="1800" b="1">
+                <a:solidFill>
+                  <a:srgbClr val="111827"/>
+                </a:solidFill>
+                <a:latin typeface="Arial"/>
+              </a:defRPr>
+            </a:pPr>
+            <a:r>
+              <a:t>References</a:t>
+            </a:r>
+          </a:p>
+        </p:txBody>
+      </p:sp>
+      <p:sp>
+        <p:nvSpPr>
+          <p:cNvPr id="65" name="TextBox 64"/>
+          <p:cNvSpPr txBox="1"/>
+          <p:nvPr/>
+        </p:nvSpPr>
+        <p:spPr>
+          <a:xfrm>
+            <a:off x="731520" y="24688800"/>
+            <a:ext cx="11155680" cy="5074920"/>
+          </a:xfrm>
+          <a:prstGeom prst="rect">
+            <a:avLst/>
+          </a:prstGeom>
+          <a:noFill/>
+        </p:spPr>
+        <p:txBody>
+          <a:bodyPr wrap="square" lIns="0" tIns="0" rIns="0" bIns="0">
+            <a:spAutoFit/>
+          </a:bodyPr>
+          <a:lstStyle/>
           <a:p>
             <a:pPr>
               <a:spcAft>
                 <a:spcPts val="200"/>
               </a:spcAft>
-              <a:defRPr sz="1000">
+              <a:defRPr sz="950">
                 <a:solidFill>
                   <a:srgbClr val="6B7280"/>
                 </a:solidFill>
@@ -6992,7 +6497,7 @@
               </a:defRPr>
             </a:pPr>
             <a:r>
-              <a:t>•  Bloom, B. S. (1984) 'The 2 sigma problem: The search for methods of group instruction as effective as one-to-one tutoring', Educational Researcher, 13(6), pp. 4–16.</a:t>
+              <a:t>•  Bastani, H. et al. (2025) 'Generative AI can harm learning: Evidence from high school classrooms'.</a:t>
             </a:r>
           </a:p>
           <a:p>
@@ -7000,7 +6505,7 @@
               <a:spcAft>
                 <a:spcPts val="200"/>
               </a:spcAft>
-              <a:defRPr sz="1000">
+              <a:defRPr sz="950">
                 <a:solidFill>
                   <a:srgbClr val="6B7280"/>
                 </a:solidFill>
@@ -7008,7 +6513,7 @@
               </a:defRPr>
             </a:pPr>
             <a:r>
-              <a:t>•  Curriculum Development Centre (CDC Nepal, 2024) Class 10 Science and Technology Textbook, Ministry of Education, Sanothimi, Bhaktapur.</a:t>
+              <a:t>•  Bloom, B. S. (1984) 'The 2 sigma problem: The search for methods of group instruction as effective as one-to-one tutoring', Educational Researcher, 13(6), pp. 4–16.</a:t>
             </a:r>
           </a:p>
           <a:p>
@@ -7016,7 +6521,7 @@
               <a:spcAft>
                 <a:spcPts val="200"/>
               </a:spcAft>
-              <a:defRPr sz="1000">
+              <a:defRPr sz="950">
                 <a:solidFill>
                   <a:srgbClr val="6B7280"/>
                 </a:solidFill>
@@ -7024,7 +6529,7 @@
               </a:defRPr>
             </a:pPr>
             <a:r>
-              <a:t>•  Lewis, P. et al. (2020) 'Retrieval-Augmented Generation for Knowledge-Intensive NLP Tasks', Advances in Neural Information Processing Systems (NeurIPS 2020).</a:t>
+              <a:t>•  Curriculum Development Centre (CDC Nepal, 2024) Class 10 Science and Technology Textbook, Ministry of Education, Sanothimi, Bhaktapur.</a:t>
             </a:r>
           </a:p>
           <a:p>
@@ -7032,7 +6537,7 @@
               <a:spcAft>
                 <a:spcPts val="200"/>
               </a:spcAft>
-              <a:defRPr sz="1000">
+              <a:defRPr sz="950">
                 <a:solidFill>
                   <a:srgbClr val="6B7280"/>
                 </a:solidFill>
@@ -7040,7 +6545,7 @@
               </a:defRPr>
             </a:pPr>
             <a:r>
-              <a:t>•  Ministry of Education, Science and Technology (MoEST, 2024) Secondary Education Examination (SEE) Results 2080-81, Sanothimi, Bhaktapur, Nepal.</a:t>
+              <a:t>•  Lewis, P. et al. (2020) 'Retrieval-Augmented Generation for Knowledge-Intensive NLP Tasks', Advances in Neural Information Processing Systems (NeurIPS 2020).</a:t>
             </a:r>
           </a:p>
           <a:p>
@@ -7048,7 +6553,7 @@
               <a:spcAft>
                 <a:spcPts val="200"/>
               </a:spcAft>
-              <a:defRPr sz="1000">
+              <a:defRPr sz="950">
                 <a:solidFill>
                   <a:srgbClr val="6B7280"/>
                 </a:solidFill>
@@ -7056,6 +6561,22 @@
               </a:defRPr>
             </a:pPr>
             <a:r>
+              <a:t>•  Ministry of Education, Science and Technology (MoEST, 2024) Secondary Education Examination (SEE) Results 2080-81, Sanothimi, Bhaktapur, Nepal.</a:t>
+            </a:r>
+          </a:p>
+          <a:p>
+            <a:pPr>
+              <a:spcAft>
+                <a:spcPts val="200"/>
+              </a:spcAft>
+              <a:defRPr sz="950">
+                <a:solidFill>
+                  <a:srgbClr val="6B7280"/>
+                </a:solidFill>
+                <a:latin typeface="Arial"/>
+              </a:defRPr>
+            </a:pPr>
+            <a:r>
               <a:t>•  Peffers, K. et al. (2007) 'A design science research methodology for information systems research', Journal of Management Information Systems, 24(3), pp. 45–77.</a:t>
             </a:r>
           </a:p>
@@ -7063,14 +6584,14 @@
       </p:sp>
       <p:sp>
         <p:nvSpPr>
-          <p:cNvPr id="81" name="TextBox 80"/>
+          <p:cNvPr id="66" name="TextBox 65"/>
           <p:cNvSpPr txBox="1"/>
           <p:nvPr/>
         </p:nvSpPr>
         <p:spPr>
           <a:xfrm>
-            <a:off x="12207240" y="21762720"/>
-            <a:ext cx="8439912" cy="502920"/>
+            <a:off x="12207240" y="20619720"/>
+            <a:ext cx="8439912" cy="365760"/>
           </a:xfrm>
           <a:prstGeom prst="rect">
             <a:avLst/>
@@ -7084,7 +6605,7 @@
           <a:lstStyle/>
           <a:p>
             <a:pPr>
-              <a:defRPr sz="2300" b="1">
+              <a:defRPr sz="2000" b="1">
                 <a:solidFill>
                   <a:srgbClr val="111827"/>
                 </a:solidFill>
@@ -7099,14 +6620,14 @@
       </p:sp>
       <p:sp>
         <p:nvSpPr>
-          <p:cNvPr id="82" name="TextBox 81"/>
+          <p:cNvPr id="67" name="TextBox 66"/>
           <p:cNvSpPr txBox="1"/>
           <p:nvPr/>
         </p:nvSpPr>
         <p:spPr>
           <a:xfrm>
-            <a:off x="12207240" y="22219920"/>
-            <a:ext cx="8439912" cy="1965960"/>
+            <a:off x="12207240" y="20985480"/>
+            <a:ext cx="8439912" cy="2011680"/>
           </a:xfrm>
           <a:prstGeom prst="rect">
             <a:avLst/>
@@ -7120,7 +6641,7 @@
           <a:lstStyle/>
           <a:p>
             <a:pPr>
-              <a:defRPr sz="1150">
+              <a:defRPr sz="1019">
                 <a:solidFill>
                   <a:srgbClr val="374151"/>
                 </a:solidFill>
@@ -7136,25 +6657,25 @@
             </a:r>
             <a:br/>
             <a:r>
-              <a:t>•  Low-Bandwidth Optimization: Lightweight JSON response payloads (&lt;500 bytes per turn) and client-side caching ensure responsive performance over 3G/2G rural mobile connections.</a:t>
+              <a:t>•  Low-Bandwidth Mobile Optimization: Ultra-lightweight JSON response payloads (&lt;500 bytes per turn) and client-side caching ensure smooth operation over patchy 2G/3G mobile data connections in rural hill districts.</a:t>
             </a:r>
             <a:br/>
             <a:r>
-              <a:t>•  Multi-Platform Access: Web app (React 18 / Vite) and cross-platform mobile client (Expo / React Native) provide seamless access across smartphones and school computer labs.</a:t>
-            </a:r>
-          </a:p>
-        </p:txBody>
-      </p:sp>
-      <p:sp>
-        <p:nvSpPr>
-          <p:cNvPr id="83" name="TextBox 82"/>
+              <a:t>•  Offline Village Edge Roadmap: Architecture designed for 4-bit GGUF quantization deployed on local community school desktop PCs and solar-powered tablets, delivering full Socratic tutoring without requiring active internet connectivity.</a:t>
+            </a:r>
+          </a:p>
+        </p:txBody>
+      </p:sp>
+      <p:sp>
+        <p:nvSpPr>
+          <p:cNvPr id="68" name="TextBox 67"/>
           <p:cNvSpPr txBox="1"/>
           <p:nvPr/>
         </p:nvSpPr>
         <p:spPr>
           <a:xfrm>
-            <a:off x="12207240" y="24414480"/>
-            <a:ext cx="8439912" cy="502920"/>
+            <a:off x="12207240" y="22997160"/>
+            <a:ext cx="8439912" cy="365760"/>
           </a:xfrm>
           <a:prstGeom prst="rect">
             <a:avLst/>
@@ -7168,7 +6689,7 @@
           <a:lstStyle/>
           <a:p>
             <a:pPr>
-              <a:defRPr sz="2300" b="1">
+              <a:defRPr sz="2000" b="1">
                 <a:solidFill>
                   <a:srgbClr val="111827"/>
                 </a:solidFill>
@@ -7183,14 +6704,14 @@
       </p:sp>
       <p:sp>
         <p:nvSpPr>
-          <p:cNvPr id="84" name="TextBox 83"/>
+          <p:cNvPr id="69" name="TextBox 68"/>
           <p:cNvSpPr txBox="1"/>
           <p:nvPr/>
         </p:nvSpPr>
         <p:spPr>
           <a:xfrm>
-            <a:off x="12207240" y="24871680"/>
-            <a:ext cx="8439912" cy="4892040"/>
+            <a:off x="12207240" y="23362920"/>
+            <a:ext cx="8439912" cy="6400800"/>
           </a:xfrm>
           <a:prstGeom prst="rect">
             <a:avLst/>
@@ -7204,7 +6725,7 @@
           <a:lstStyle/>
           <a:p>
             <a:pPr>
-              <a:defRPr sz="1100">
+              <a:defRPr sz="1019">
                 <a:solidFill>
                   <a:srgbClr val="374151"/>
                 </a:solidFill>
@@ -7254,7 +6775,7 @@
             </a:r>
             <a:br/>
             <a:r>
-              <a:t>•  Professional Standards: Adherence to BCS Code of Conduct and ACM Code of Ethics.</a:t>
+              <a:t>•  Professional Standards: Strict adherence to BCS Code of Conduct and ACM Code of Ethics.</a:t>
             </a:r>
           </a:p>
         </p:txBody>

</xml_diff>